<commit_message>
Process deck: larger roadmap type
</commit_message>
<xml_diff>
--- a/jaspersoft/docs/OriginBA_Automated_Deployment.pptx
+++ b/jaspersoft/docs/OriginBA_Automated_Deployment.pptx
@@ -8732,7 +8732,7 @@
               </a:spcAft>
             </a:pPr>
             <a:r>
-              <a:rPr sz="2200" b="1">
+              <a:rPr sz="2400" b="1">
                 <a:solidFill>
                   <a:srgbClr val="0B3D7A"/>
                 </a:solidFill>
@@ -8747,7 +8747,7 @@
               </a:spcAft>
             </a:pPr>
             <a:r>
-              <a:rPr sz="1600" b="0">
+              <a:rPr sz="1800" b="0">
                 <a:solidFill>
                   <a:srgbClr val="4C5D69"/>
                 </a:solidFill>
@@ -8762,7 +8762,7 @@
               </a:spcAft>
             </a:pPr>
             <a:r>
-              <a:rPr sz="1400" b="0">
+              <a:rPr sz="1800" b="0">
                 <a:solidFill>
                   <a:srgbClr val="4C5D69"/>
                 </a:solidFill>
@@ -8876,7 +8876,7 @@
               </a:spcAft>
             </a:pPr>
             <a:r>
-              <a:rPr sz="2200" b="1">
+              <a:rPr sz="2400" b="1">
                 <a:solidFill>
                   <a:srgbClr val="0B3D7A"/>
                 </a:solidFill>
@@ -8891,7 +8891,7 @@
               </a:spcAft>
             </a:pPr>
             <a:r>
-              <a:rPr sz="1600" b="0">
+              <a:rPr sz="1800" b="0">
                 <a:solidFill>
                   <a:srgbClr val="4C5D69"/>
                 </a:solidFill>
@@ -8906,7 +8906,7 @@
               </a:spcAft>
             </a:pPr>
             <a:r>
-              <a:rPr sz="1400" b="0">
+              <a:rPr sz="1800" b="0">
                 <a:solidFill>
                   <a:srgbClr val="4C5D69"/>
                 </a:solidFill>
@@ -9020,7 +9020,7 @@
               </a:spcAft>
             </a:pPr>
             <a:r>
-              <a:rPr sz="2200" b="1">
+              <a:rPr sz="2400" b="1">
                 <a:solidFill>
                   <a:srgbClr val="0B3D7A"/>
                 </a:solidFill>
@@ -9035,7 +9035,7 @@
               </a:spcAft>
             </a:pPr>
             <a:r>
-              <a:rPr sz="1600" b="0">
+              <a:rPr sz="1800" b="0">
                 <a:solidFill>
                   <a:srgbClr val="4C5D69"/>
                 </a:solidFill>
@@ -9050,7 +9050,7 @@
               </a:spcAft>
             </a:pPr>
             <a:r>
-              <a:rPr sz="1400" b="0">
+              <a:rPr sz="1800" b="0">
                 <a:solidFill>
                   <a:srgbClr val="4C5D69"/>
                 </a:solidFill>
@@ -9164,7 +9164,7 @@
               </a:spcAft>
             </a:pPr>
             <a:r>
-              <a:rPr sz="2200" b="1">
+              <a:rPr sz="2400" b="1">
                 <a:solidFill>
                   <a:srgbClr val="0B3D7A"/>
                 </a:solidFill>
@@ -9179,7 +9179,7 @@
               </a:spcAft>
             </a:pPr>
             <a:r>
-              <a:rPr sz="1600" b="0">
+              <a:rPr sz="1800" b="0">
                 <a:solidFill>
                   <a:srgbClr val="4C5D69"/>
                 </a:solidFill>
@@ -9194,7 +9194,7 @@
               </a:spcAft>
             </a:pPr>
             <a:r>
-              <a:rPr sz="1400" b="0">
+              <a:rPr sz="1800" b="0">
                 <a:solidFill>
                   <a:srgbClr val="4C5D69"/>
                 </a:solidFill>
@@ -9308,7 +9308,7 @@
               </a:spcAft>
             </a:pPr>
             <a:r>
-              <a:rPr sz="2200" b="1">
+              <a:rPr sz="2400" b="1">
                 <a:solidFill>
                   <a:srgbClr val="0B3D7A"/>
                 </a:solidFill>
@@ -9323,7 +9323,7 @@
               </a:spcAft>
             </a:pPr>
             <a:r>
-              <a:rPr sz="1600" b="0">
+              <a:rPr sz="1800" b="0">
                 <a:solidFill>
                   <a:srgbClr val="0B3D7A"/>
                 </a:solidFill>
@@ -9338,7 +9338,7 @@
               </a:spcAft>
             </a:pPr>
             <a:r>
-              <a:rPr sz="1400" b="0">
+              <a:rPr sz="1800" b="0">
                 <a:solidFill>
                   <a:srgbClr val="0B3D7A"/>
                 </a:solidFill>

</xml_diff>

<commit_message>
Deployment deck: title fits one line, roadmap boxes sized to content
</commit_message>
<xml_diff>
--- a/jaspersoft/docs/OriginBA_Automated_Deployment.pptx
+++ b/jaspersoft/docs/OriginBA_Automated_Deployment.pptx
@@ -7671,7 +7671,7 @@
         <p:spPr>
           <a:xfrm>
             <a:off x="740664" y="384048"/>
-            <a:ext cx="13716000" cy="960120"/>
+            <a:ext cx="18653760" cy="960120"/>
           </a:xfrm>
           <a:prstGeom prst="rect">
             <a:avLst/>
@@ -7695,7 +7695,7 @@
                   <a:srgbClr val="F5EFE9"/>
                 </a:solidFill>
               </a:rPr>
-              <a:t>A Worked Example: College Station, One Morning</a:t>
+              <a:t>Worked Example: College Station</a:t>
             </a:r>
           </a:p>
         </p:txBody>
@@ -7805,11 +7805,11 @@
         <p:spPr>
           <a:xfrm>
             <a:off x="740664" y="6099048"/>
-            <a:ext cx="3465576" cy="3383280"/>
+            <a:ext cx="3465576" cy="2834640"/>
           </a:xfrm>
           <a:prstGeom prst="roundRect">
             <a:avLst>
-              <a:gd name="adj" fmla="val 12000"/>
+              <a:gd name="adj" fmla="val 10000"/>
             </a:avLst>
           </a:prstGeom>
           <a:solidFill>
@@ -7949,11 +7949,11 @@
         <p:spPr>
           <a:xfrm>
             <a:off x="4535424" y="6099048"/>
-            <a:ext cx="3465576" cy="3383280"/>
+            <a:ext cx="3465576" cy="2834640"/>
           </a:xfrm>
           <a:prstGeom prst="roundRect">
             <a:avLst>
-              <a:gd name="adj" fmla="val 12000"/>
+              <a:gd name="adj" fmla="val 10000"/>
             </a:avLst>
           </a:prstGeom>
           <a:solidFill>
@@ -8093,11 +8093,11 @@
         <p:spPr>
           <a:xfrm>
             <a:off x="8330184" y="6099048"/>
-            <a:ext cx="3465576" cy="3383280"/>
+            <a:ext cx="3465576" cy="2834640"/>
           </a:xfrm>
           <a:prstGeom prst="roundRect">
             <a:avLst>
-              <a:gd name="adj" fmla="val 12000"/>
+              <a:gd name="adj" fmla="val 10000"/>
             </a:avLst>
           </a:prstGeom>
           <a:solidFill>
@@ -8237,11 +8237,11 @@
         <p:spPr>
           <a:xfrm>
             <a:off x="12124944" y="6099048"/>
-            <a:ext cx="3465576" cy="3383280"/>
+            <a:ext cx="3465576" cy="2834640"/>
           </a:xfrm>
           <a:prstGeom prst="roundRect">
             <a:avLst>
-              <a:gd name="adj" fmla="val 12000"/>
+              <a:gd name="adj" fmla="val 10000"/>
             </a:avLst>
           </a:prstGeom>
           <a:solidFill>
@@ -8381,11 +8381,11 @@
         <p:spPr>
           <a:xfrm>
             <a:off x="15919704" y="6099048"/>
-            <a:ext cx="3465576" cy="3383280"/>
+            <a:ext cx="3465576" cy="2834640"/>
           </a:xfrm>
           <a:prstGeom prst="roundRect">
             <a:avLst>
-              <a:gd name="adj" fmla="val 12000"/>
+              <a:gd name="adj" fmla="val 10000"/>
             </a:avLst>
           </a:prstGeom>
           <a:solidFill>
@@ -8524,7 +8524,7 @@
         </p:nvSpPr>
         <p:spPr>
           <a:xfrm>
-            <a:off x="740664" y="1828800"/>
+            <a:off x="740664" y="2103120"/>
             <a:ext cx="18288000" cy="2377440"/>
           </a:xfrm>
           <a:prstGeom prst="rect">
@@ -8549,7 +8549,7 @@
                   <a:srgbClr val="F5EFE9"/>
                 </a:solidFill>
               </a:rPr>
-              <a:t>21 production reports the client asked to have in Test: 20 Ad Hoc views, 1 report, and the 13 domains behind them.</a:t>
+              <a:t>One morning, 21 production reports the client asked to have in Test: 20 Ad Hoc views, 1 report, and the 13 domains behind them.</a:t>
             </a:r>
           </a:p>
         </p:txBody>
@@ -8581,7 +8581,7 @@
         <p:spPr>
           <a:xfrm>
             <a:off x="740664" y="384048"/>
-            <a:ext cx="13716000" cy="960120"/>
+            <a:ext cx="18653760" cy="960120"/>
           </a:xfrm>
           <a:prstGeom prst="rect">
             <a:avLst/>
@@ -9278,7 +9278,7 @@
         <p:spPr>
           <a:xfrm>
             <a:off x="740664" y="384048"/>
-            <a:ext cx="13716000" cy="960120"/>
+            <a:ext cx="18653760" cy="960120"/>
           </a:xfrm>
           <a:prstGeom prst="rect">
             <a:avLst/>
@@ -10039,7 +10039,7 @@
         <p:spPr>
           <a:xfrm>
             <a:off x="740664" y="384048"/>
-            <a:ext cx="13716000" cy="960120"/>
+            <a:ext cx="18653760" cy="960120"/>
           </a:xfrm>
           <a:prstGeom prst="rect">
             <a:avLst/>
@@ -10442,7 +10442,7 @@
         <p:spPr>
           <a:xfrm>
             <a:off x="740664" y="384048"/>
-            <a:ext cx="13716000" cy="960120"/>
+            <a:ext cx="18653760" cy="960120"/>
           </a:xfrm>
           <a:prstGeom prst="rect">
             <a:avLst/>
@@ -10845,7 +10845,7 @@
         <p:spPr>
           <a:xfrm>
             <a:off x="740664" y="384048"/>
-            <a:ext cx="13716000" cy="960120"/>
+            <a:ext cx="18653760" cy="960120"/>
           </a:xfrm>
           <a:prstGeom prst="rect">
             <a:avLst/>
@@ -10979,11 +10979,11 @@
         <p:spPr>
           <a:xfrm>
             <a:off x="740664" y="6099048"/>
-            <a:ext cx="3465576" cy="3383280"/>
+            <a:ext cx="3465576" cy="2834640"/>
           </a:xfrm>
           <a:prstGeom prst="roundRect">
             <a:avLst>
-              <a:gd name="adj" fmla="val 12000"/>
+              <a:gd name="adj" fmla="val 10000"/>
             </a:avLst>
           </a:prstGeom>
           <a:solidFill>
@@ -11123,11 +11123,11 @@
         <p:spPr>
           <a:xfrm>
             <a:off x="4535424" y="6099048"/>
-            <a:ext cx="3465576" cy="3383280"/>
+            <a:ext cx="3465576" cy="2834640"/>
           </a:xfrm>
           <a:prstGeom prst="roundRect">
             <a:avLst>
-              <a:gd name="adj" fmla="val 12000"/>
+              <a:gd name="adj" fmla="val 10000"/>
             </a:avLst>
           </a:prstGeom>
           <a:solidFill>
@@ -11267,11 +11267,11 @@
         <p:spPr>
           <a:xfrm>
             <a:off x="8330184" y="6099048"/>
-            <a:ext cx="3465576" cy="3383280"/>
+            <a:ext cx="3465576" cy="2834640"/>
           </a:xfrm>
           <a:prstGeom prst="roundRect">
             <a:avLst>
-              <a:gd name="adj" fmla="val 12000"/>
+              <a:gd name="adj" fmla="val 10000"/>
             </a:avLst>
           </a:prstGeom>
           <a:solidFill>
@@ -11411,11 +11411,11 @@
         <p:spPr>
           <a:xfrm>
             <a:off x="12124944" y="6099048"/>
-            <a:ext cx="3465576" cy="3383280"/>
+            <a:ext cx="3465576" cy="2834640"/>
           </a:xfrm>
           <a:prstGeom prst="roundRect">
             <a:avLst>
-              <a:gd name="adj" fmla="val 12000"/>
+              <a:gd name="adj" fmla="val 10000"/>
             </a:avLst>
           </a:prstGeom>
           <a:solidFill>
@@ -11555,11 +11555,11 @@
         <p:spPr>
           <a:xfrm>
             <a:off x="15919704" y="6099048"/>
-            <a:ext cx="3465576" cy="3383280"/>
+            <a:ext cx="3465576" cy="2834640"/>
           </a:xfrm>
           <a:prstGeom prst="roundRect">
             <a:avLst>
-              <a:gd name="adj" fmla="val 12000"/>
+              <a:gd name="adj" fmla="val 10000"/>
             </a:avLst>
           </a:prstGeom>
           <a:solidFill>
@@ -11698,7 +11698,7 @@
         </p:nvSpPr>
         <p:spPr>
           <a:xfrm>
-            <a:off x="740664" y="1828800"/>
+            <a:off x="740664" y="2103120"/>
             <a:ext cx="18288000" cy="2377440"/>
           </a:xfrm>
           <a:prstGeom prst="rect">
@@ -11755,7 +11755,7 @@
         <p:spPr>
           <a:xfrm>
             <a:off x="740664" y="384048"/>
-            <a:ext cx="13716000" cy="960120"/>
+            <a:ext cx="18653760" cy="960120"/>
           </a:xfrm>
           <a:prstGeom prst="rect">
             <a:avLst/>
@@ -12469,7 +12469,7 @@
         <p:spPr>
           <a:xfrm>
             <a:off x="740664" y="384048"/>
-            <a:ext cx="13716000" cy="960120"/>
+            <a:ext cx="18653760" cy="960120"/>
           </a:xfrm>
           <a:prstGeom prst="rect">
             <a:avLst/>
@@ -13937,7 +13937,7 @@
         <p:spPr>
           <a:xfrm>
             <a:off x="740664" y="384048"/>
-            <a:ext cx="13716000" cy="960120"/>
+            <a:ext cx="18653760" cy="960120"/>
           </a:xfrm>
           <a:prstGeom prst="rect">
             <a:avLst/>
@@ -15000,7 +15000,7 @@
         <p:spPr>
           <a:xfrm>
             <a:off x="740664" y="384048"/>
-            <a:ext cx="13716000" cy="960120"/>
+            <a:ext cx="18653760" cy="960120"/>
           </a:xfrm>
           <a:prstGeom prst="rect">
             <a:avLst/>
@@ -16405,7 +16405,7 @@
         <p:spPr>
           <a:xfrm>
             <a:off x="740664" y="384048"/>
-            <a:ext cx="13716000" cy="960120"/>
+            <a:ext cx="18653760" cy="960120"/>
           </a:xfrm>
           <a:prstGeom prst="rect">
             <a:avLst/>
@@ -17890,7 +17890,7 @@
         <p:spPr>
           <a:xfrm>
             <a:off x="740664" y="384048"/>
-            <a:ext cx="13716000" cy="960120"/>
+            <a:ext cx="18653760" cy="960120"/>
           </a:xfrm>
           <a:prstGeom prst="rect">
             <a:avLst/>
@@ -19170,7 +19170,7 @@
         <p:spPr>
           <a:xfrm>
             <a:off x="740664" y="384048"/>
-            <a:ext cx="13716000" cy="960120"/>
+            <a:ext cx="18653760" cy="960120"/>
           </a:xfrm>
           <a:prstGeom prst="rect">
             <a:avLst/>
@@ -20430,7 +20430,7 @@
         <p:spPr>
           <a:xfrm>
             <a:off x="740664" y="384048"/>
-            <a:ext cx="13716000" cy="960120"/>
+            <a:ext cx="18653760" cy="960120"/>
           </a:xfrm>
           <a:prstGeom prst="rect">
             <a:avLst/>
@@ -21974,7 +21974,7 @@
         <p:spPr>
           <a:xfrm>
             <a:off x="740664" y="384048"/>
-            <a:ext cx="13716000" cy="960120"/>
+            <a:ext cx="18653760" cy="960120"/>
           </a:xfrm>
           <a:prstGeom prst="rect">
             <a:avLst/>

</xml_diff>

<commit_message>
Process deck: card slides take a stat callout and a single-row block sits centred; Results, Measured leads with 100% / 11 min / 6 orgs
Co-Authored-By: Claude Fable 5.1 <noreply@anthropic.com>
</commit_message>
<xml_diff>
--- a/jaspersoft/docs/OriginBA_Automated_Deployment.pptx
+++ b/jaspersoft/docs/OriginBA_Automated_Deployment.pptx
@@ -7743,8 +7743,8 @@
         </p:nvSpPr>
         <p:spPr>
           <a:xfrm>
-            <a:off x="740664" y="1828800"/>
-            <a:ext cx="5913119" cy="3429000"/>
+            <a:off x="740664" y="3223260"/>
+            <a:ext cx="5913119" cy="5349240"/>
           </a:xfrm>
           <a:prstGeom prst="roundRect">
             <a:avLst>
@@ -7783,6 +7783,36 @@
               </a:spcAft>
             </a:pPr>
             <a:r>
+              <a:rPr sz="6000" b="1">
+                <a:solidFill>
+                  <a:srgbClr val="0B3D7A"/>
+                </a:solidFill>
+              </a:rPr>
+              <a:t>100%</a:t>
+            </a:r>
+          </a:p>
+          <a:p>
+            <a:pPr algn="l">
+              <a:spcAft>
+                <a:spcPts val="600"/>
+              </a:spcAft>
+            </a:pPr>
+            <a:r>
+              <a:rPr sz="1800" b="0">
+                <a:solidFill>
+                  <a:srgbClr val="4C5D69"/>
+                </a:solidFill>
+              </a:rPr>
+              <a:t>138,086 of 138,086 SA balances tie to the cent</a:t>
+            </a:r>
+          </a:p>
+          <a:p>
+            <a:pPr algn="l">
+              <a:spcAft>
+                <a:spcPts val="600"/>
+              </a:spcAft>
+            </a:pPr>
+            <a:r>
               <a:rPr sz="3000" b="1">
                 <a:solidFill>
                   <a:srgbClr val="0B3D7A"/>
@@ -7803,7 +7833,7 @@
                   <a:srgbClr val="4C5D69"/>
                 </a:solidFill>
               </a:rPr>
-              <a:t>Ellensburg, CityCorp, College Station, Newark on the twice-daily schedule</a:t>
+              <a:t>Ellensburg, CityCorp, College Station, Newark refreshed twice daily</a:t>
             </a:r>
           </a:p>
           <a:p>
@@ -7819,21 +7849,6 @@
                 </a:solidFill>
               </a:rPr>
               <a:t>Baselines run as parallel jobs, gated, unattended</a:t>
-            </a:r>
-          </a:p>
-          <a:p>
-            <a:pPr algn="l">
-              <a:spcAft>
-                <a:spcPts val="600"/>
-              </a:spcAft>
-            </a:pPr>
-            <a:r>
-              <a:rPr sz="2200" b="0">
-                <a:solidFill>
-                  <a:srgbClr val="4C5D69"/>
-                </a:solidFill>
-              </a:rPr>
-              <a:t>138,086 of 138,086 balances tie to the cent</a:t>
             </a:r>
           </a:p>
         </p:txBody>
@@ -7846,8 +7861,8 @@
         </p:nvSpPr>
         <p:spPr>
           <a:xfrm>
-            <a:off x="7110983" y="1828800"/>
-            <a:ext cx="5913119" cy="3429000"/>
+            <a:off x="7110983" y="3223260"/>
+            <a:ext cx="5913119" cy="5349240"/>
           </a:xfrm>
           <a:prstGeom prst="roundRect">
             <a:avLst>
@@ -7886,6 +7901,36 @@
               </a:spcAft>
             </a:pPr>
             <a:r>
+              <a:rPr sz="6000" b="1">
+                <a:solidFill>
+                  <a:srgbClr val="0B3D7A"/>
+                </a:solidFill>
+              </a:rPr>
+              <a:t>11 min</a:t>
+            </a:r>
+          </a:p>
+          <a:p>
+            <a:pPr algn="l">
+              <a:spcAft>
+                <a:spcPts val="600"/>
+              </a:spcAft>
+            </a:pPr>
+            <a:r>
+              <a:rPr sz="1800" b="0">
+                <a:solidFill>
+                  <a:srgbClr val="4C5D69"/>
+                </a:solidFill>
+              </a:rPr>
+              <a:t>Ellensburg, test org to prod org, 0 errors</a:t>
+            </a:r>
+          </a:p>
+          <a:p>
+            <a:pPr algn="l">
+              <a:spcAft>
+                <a:spcPts val="600"/>
+              </a:spcAft>
+            </a:pPr>
+            <a:r>
               <a:rPr sz="3000" b="1">
                 <a:solidFill>
                   <a:srgbClr val="0B3D7A"/>
@@ -7906,7 +7951,7 @@
                   <a:srgbClr val="4C5D69"/>
                 </a:solidFill>
               </a:rPr>
-              <a:t>Ellensburg 11 minutes: 116 ok, 7 empty, 27 slow, 0 errors</a:t>
+              <a:t>Newark 21 minutes, 0 errors</a:t>
             </a:r>
           </a:p>
           <a:p>
@@ -7921,7 +7966,7 @@
                   <a:srgbClr val="4C5D69"/>
                 </a:solidFill>
               </a:rPr>
-              <a:t>Newark 21 minutes, 0 errors</a:t>
+              <a:t>116 ok, 7 empty, 27 slow on the first sweep</a:t>
             </a:r>
           </a:p>
           <a:p>
@@ -7949,8 +7994,8 @@
         </p:nvSpPr>
         <p:spPr>
           <a:xfrm>
-            <a:off x="13481303" y="1828800"/>
-            <a:ext cx="5913119" cy="3429000"/>
+            <a:off x="13481303" y="3223260"/>
+            <a:ext cx="5913119" cy="5349240"/>
           </a:xfrm>
           <a:prstGeom prst="roundRect">
             <a:avLst>
@@ -7989,27 +8034,42 @@
               </a:spcAft>
             </a:pPr>
             <a:r>
+              <a:rPr sz="6000" b="1">
+                <a:solidFill>
+                  <a:srgbClr val="0B3D7A"/>
+                </a:solidFill>
+              </a:rPr>
+              <a:t>6 orgs</a:t>
+            </a:r>
+          </a:p>
+          <a:p>
+            <a:pPr algn="l">
+              <a:spcAft>
+                <a:spcPts val="600"/>
+              </a:spcAft>
+            </a:pPr>
+            <a:r>
+              <a:rPr sz="1800" b="0">
+                <a:solidFill>
+                  <a:srgbClr val="4C5D69"/>
+                </a:solidFill>
+              </a:rPr>
+              <a:t>one domain change, seven proofs each, in an afternoon</a:t>
+            </a:r>
+          </a:p>
+          <a:p>
+            <a:pPr algn="l">
+              <a:spcAft>
+                <a:spcPts val="600"/>
+              </a:spcAft>
+            </a:pPr>
+            <a:r>
               <a:rPr sz="3000" b="1">
                 <a:solidFill>
                   <a:srgbClr val="0B3D7A"/>
                 </a:solidFill>
               </a:rPr>
               <a:t>Day-to-day changes</a:t>
-            </a:r>
-          </a:p>
-          <a:p>
-            <a:pPr algn="l">
-              <a:spcAft>
-                <a:spcPts val="600"/>
-              </a:spcAft>
-            </a:pPr>
-            <a:r>
-              <a:rPr sz="2200" b="0">
-                <a:solidFill>
-                  <a:srgbClr val="4C5D69"/>
-                </a:solidFill>
-              </a:rPr>
-              <a:t>Adjustment domain exact on six client orgs in an afternoon</a:t>
             </a:r>
           </a:p>
           <a:p>

</xml_diff>

<commit_message>
Diagram QA: flat table boxes instead of cylinders, the one diagonal arrow straightened, 200 dpi PNGs; rolling-window facts corrected to what the procedures do (3 months rebuilt, 24 kept, on every table; 6-month at CityCorp and Odessa; the baseline loads the retained 24 months) in the visuals, the deck and the companion
Co-Authored-By: Claude Fable 5.1 <noreply@anthropic.com>
</commit_message>
<xml_diff>
--- a/jaspersoft/docs/OriginBA_Automated_Deployment.pptx
+++ b/jaspersoft/docs/OriginBA_Automated_Deployment.pptx
@@ -9655,7 +9655,7 @@
                   <a:srgbClr val="4C5D69"/>
                 </a:solidFill>
               </a:rPr>
-              <a:t>loads every year of history once, one job per table</a:t>
+              <a:t>loads the retained 24 months once, one job per table</a:t>
             </a:r>
           </a:p>
         </p:txBody>
@@ -10224,7 +10224,7 @@
                   <a:srgbClr val="4C5D69"/>
                 </a:solidFill>
               </a:rPr>
-              <a:t>12 months; 6 at CityCorp and Odessa; 3 rolling with 24 kept at College Station and Newark</a:t>
+              <a:t>3 months rebuilt, 24 kept, on every table; 6-month rolling at CityCorp and Odessa</a:t>
             </a:r>
           </a:p>
         </p:txBody>
@@ -15462,7 +15462,7 @@
                   <a:srgbClr val="4C5D69"/>
                 </a:solidFill>
               </a:rPr>
-              <a:t>scheduled SQL reports in one place on every org, promoted by the same tool</a:t>
+              <a:t>scheduled SQL reports in one folder; on Origin_DEV today, promoted to client orgs by the same tool when approved</a:t>
             </a:r>
           </a:p>
         </p:txBody>
@@ -21086,7 +21086,7 @@
                   <a:srgbClr val="0B3D7A"/>
                 </a:solidFill>
               </a:rPr>
-              <a:t>8 reporting tables (the active 8) loaded once from full history</a:t>
+              <a:t>8 reporting tables (the active 8) loaded once from the retained history</a:t>
             </a:r>
           </a:p>
         </p:txBody>
@@ -21144,7 +21144,7 @@
                   <a:srgbClr val="0B3D7A"/>
                 </a:solidFill>
               </a:rPr>
-              <a:t>Refresh procedures: full history for the baseline, then a rolling window</a:t>
+              <a:t>Refresh procedures: the retained 24 months once, then a rolling window</a:t>
             </a:r>
           </a:p>
         </p:txBody>
@@ -33376,7 +33376,7 @@
                   <a:srgbClr val="4C5D69"/>
                 </a:solidFill>
               </a:rPr>
-              <a:t>baseline (24 months, once) and operational per table; SA refresh</a:t>
+              <a:t>baseline (the retained 24 months, once) and operational per table; the SA aged-balance refresh</a:t>
             </a:r>
           </a:p>
         </p:txBody>
@@ -34227,7 +34227,7 @@
                   <a:srgbClr val="4C5D69"/>
                 </a:solidFill>
               </a:rPr>
-              <a:t>twice daily, 30-minute stagger, held on TEST until approved</a:t>
+              <a:t>twice daily from 10:00 and 16:00 UTC, 30-minute stagger; held on TEST until approved</a:t>
             </a:r>
           </a:p>
         </p:txBody>
@@ -34338,7 +34338,7 @@
                   <a:srgbClr val="F5EFE9"/>
                 </a:solidFill>
               </a:rPr>
-              <a:t>Finance</a:t>
+              <a:t>Finance tables</a:t>
             </a:r>
           </a:p>
         </p:txBody>
@@ -34376,7 +34376,7 @@
                   <a:srgbClr val="F5EFE9"/>
                 </a:solidFill>
               </a:rPr>
-              <a:t>Billing and Rates</a:t>
+              <a:t>Billing and Rates tables</a:t>
             </a:r>
           </a:p>
         </p:txBody>
@@ -34414,7 +34414,7 @@
                   <a:srgbClr val="F5EFE9"/>
                 </a:solidFill>
               </a:rPr>
-              <a:t>Meter Operations</a:t>
+              <a:t>Meter Operations tables</a:t>
             </a:r>
           </a:p>
         </p:txBody>
@@ -34452,7 +34452,7 @@
                   <a:srgbClr val="F5EFE9"/>
                 </a:solidFill>
               </a:rPr>
-              <a:t>Debt Management</a:t>
+              <a:t>Debt Management table + seed</a:t>
             </a:r>
           </a:p>
         </p:txBody>
@@ -34573,7 +34573,7 @@
       </p:sp>
       <p:sp>
         <p:nvSpPr>
-          <p:cNvPr id="35" name="Can 34"/>
+          <p:cNvPr id="35" name="Rounded Rectangle 34"/>
           <p:cNvSpPr/>
           <p:nvPr/>
         </p:nvSpPr>
@@ -34582,8 +34582,10 @@
             <a:off x="868680" y="6675120"/>
             <a:ext cx="2103120" cy="822960"/>
           </a:xfrm>
-          <a:prstGeom prst="can">
-            <a:avLst/>
+          <a:prstGeom prst="roundRect">
+            <a:avLst>
+              <a:gd name="adj" fmla="val 10000"/>
+            </a:avLst>
           </a:prstGeom>
           <a:solidFill>
             <a:srgbClr val="F5EFE9"/>
@@ -34644,7 +34646,7 @@
       </p:sp>
       <p:sp>
         <p:nvSpPr>
-          <p:cNvPr id="36" name="Can 35"/>
+          <p:cNvPr id="36" name="Rounded Rectangle 35"/>
           <p:cNvSpPr/>
           <p:nvPr/>
         </p:nvSpPr>
@@ -34653,8 +34655,10 @@
             <a:off x="868680" y="7635240"/>
             <a:ext cx="2103120" cy="822960"/>
           </a:xfrm>
-          <a:prstGeom prst="can">
-            <a:avLst/>
+          <a:prstGeom prst="roundRect">
+            <a:avLst>
+              <a:gd name="adj" fmla="val 10000"/>
+            </a:avLst>
           </a:prstGeom>
           <a:solidFill>
             <a:srgbClr val="F5EFE9"/>
@@ -34715,7 +34719,7 @@
       </p:sp>
       <p:sp>
         <p:nvSpPr>
-          <p:cNvPr id="37" name="Can 36"/>
+          <p:cNvPr id="37" name="Rounded Rectangle 36"/>
           <p:cNvSpPr/>
           <p:nvPr/>
         </p:nvSpPr>
@@ -34724,8 +34728,10 @@
             <a:off x="3108960" y="6675120"/>
             <a:ext cx="2103120" cy="822960"/>
           </a:xfrm>
-          <a:prstGeom prst="can">
-            <a:avLst/>
+          <a:prstGeom prst="roundRect">
+            <a:avLst>
+              <a:gd name="adj" fmla="val 10000"/>
+            </a:avLst>
           </a:prstGeom>
           <a:solidFill>
             <a:srgbClr val="F5EFE9"/>
@@ -34786,7 +34792,7 @@
       </p:sp>
       <p:sp>
         <p:nvSpPr>
-          <p:cNvPr id="38" name="Can 37"/>
+          <p:cNvPr id="38" name="Rounded Rectangle 37"/>
           <p:cNvSpPr/>
           <p:nvPr/>
         </p:nvSpPr>
@@ -34795,8 +34801,10 @@
             <a:off x="3108960" y="7635240"/>
             <a:ext cx="2103120" cy="822960"/>
           </a:xfrm>
-          <a:prstGeom prst="can">
-            <a:avLst/>
+          <a:prstGeom prst="roundRect">
+            <a:avLst>
+              <a:gd name="adj" fmla="val 10000"/>
+            </a:avLst>
           </a:prstGeom>
           <a:solidFill>
             <a:srgbClr val="F5EFE9"/>
@@ -34857,7 +34865,7 @@
       </p:sp>
       <p:sp>
         <p:nvSpPr>
-          <p:cNvPr id="39" name="Can 38"/>
+          <p:cNvPr id="39" name="Rounded Rectangle 38"/>
           <p:cNvSpPr/>
           <p:nvPr/>
         </p:nvSpPr>
@@ -34866,8 +34874,10 @@
             <a:off x="5349240" y="6675120"/>
             <a:ext cx="2103120" cy="594360"/>
           </a:xfrm>
-          <a:prstGeom prst="can">
-            <a:avLst/>
+          <a:prstGeom prst="roundRect">
+            <a:avLst>
+              <a:gd name="adj" fmla="val 10000"/>
+            </a:avLst>
           </a:prstGeom>
           <a:solidFill>
             <a:srgbClr val="F5EFE9"/>
@@ -34928,7 +34938,7 @@
       </p:sp>
       <p:sp>
         <p:nvSpPr>
-          <p:cNvPr id="40" name="Can 39"/>
+          <p:cNvPr id="40" name="Rounded Rectangle 39"/>
           <p:cNvSpPr/>
           <p:nvPr/>
         </p:nvSpPr>
@@ -34937,8 +34947,10 @@
             <a:off x="5349240" y="7360920"/>
             <a:ext cx="2103120" cy="594360"/>
           </a:xfrm>
-          <a:prstGeom prst="can">
-            <a:avLst/>
+          <a:prstGeom prst="roundRect">
+            <a:avLst>
+              <a:gd name="adj" fmla="val 10000"/>
+            </a:avLst>
           </a:prstGeom>
           <a:solidFill>
             <a:srgbClr val="F5EFE9"/>
@@ -34999,7 +35011,7 @@
       </p:sp>
       <p:sp>
         <p:nvSpPr>
-          <p:cNvPr id="41" name="Can 40"/>
+          <p:cNvPr id="41" name="Rounded Rectangle 40"/>
           <p:cNvSpPr/>
           <p:nvPr/>
         </p:nvSpPr>
@@ -35008,8 +35020,10 @@
             <a:off x="5349240" y="8046720"/>
             <a:ext cx="2103120" cy="594360"/>
           </a:xfrm>
-          <a:prstGeom prst="can">
-            <a:avLst/>
+          <a:prstGeom prst="roundRect">
+            <a:avLst>
+              <a:gd name="adj" fmla="val 10000"/>
+            </a:avLst>
           </a:prstGeom>
           <a:solidFill>
             <a:srgbClr val="F5EFE9"/>
@@ -35244,7 +35258,7 @@
       </p:sp>
       <p:sp>
         <p:nvSpPr>
-          <p:cNvPr id="45" name="Can 44"/>
+          <p:cNvPr id="45" name="Rounded Rectangle 44"/>
           <p:cNvSpPr/>
           <p:nvPr/>
         </p:nvSpPr>
@@ -35253,8 +35267,10 @@
             <a:off x="7863840" y="6675120"/>
             <a:ext cx="2377440" cy="868680"/>
           </a:xfrm>
-          <a:prstGeom prst="can">
-            <a:avLst/>
+          <a:prstGeom prst="roundRect">
+            <a:avLst>
+              <a:gd name="adj" fmla="val 10000"/>
+            </a:avLst>
           </a:prstGeom>
           <a:solidFill>
             <a:srgbClr val="F5EFE9"/>
@@ -36351,7 +36367,7 @@
         <p:spPr>
           <a:xfrm>
             <a:off x="15828263" y="3474720"/>
-            <a:ext cx="2322577" cy="228600"/>
+            <a:ext cx="0" cy="274319"/>
           </a:xfrm>
           <a:prstGeom prst="line">
             <a:avLst/>
@@ -36384,9 +36400,44 @@
           <p:nvPr/>
         </p:nvCxnSpPr>
         <p:spPr>
+          <a:xfrm>
+            <a:off x="15828263" y="3749039"/>
+            <a:ext cx="2322577" cy="0"/>
+          </a:xfrm>
+          <a:prstGeom prst="line">
+            <a:avLst/>
+          </a:prstGeom>
+          <a:ln w="28575">
+            <a:solidFill>
+              <a:srgbClr val="F5EFE9"/>
+            </a:solidFill>
+          </a:ln>
+        </p:spPr>
+        <p:style>
+          <a:lnRef idx="2">
+            <a:schemeClr val="accent1"/>
+          </a:lnRef>
+          <a:fillRef idx="0">
+            <a:schemeClr val="accent1"/>
+          </a:fillRef>
+          <a:effectRef idx="1">
+            <a:schemeClr val="accent1"/>
+          </a:effectRef>
+          <a:fontRef idx="minor">
+            <a:schemeClr val="tx1"/>
+          </a:fontRef>
+        </p:style>
+      </p:cxnSp>
+      <p:cxnSp>
+        <p:nvCxnSpPr>
+          <p:cNvPr id="67" name="Connector 66"/>
+          <p:cNvCxnSpPr/>
+          <p:nvPr/>
+        </p:nvCxnSpPr>
+        <p:spPr>
           <a:xfrm flipH="1">
-            <a:off x="18150839" y="3703320"/>
-            <a:ext cx="1" cy="320040"/>
+            <a:off x="18150839" y="3749039"/>
+            <a:ext cx="1" cy="274321"/>
           </a:xfrm>
           <a:prstGeom prst="line">
             <a:avLst/>
@@ -36415,7 +36466,7 @@
       </p:cxnSp>
       <p:cxnSp>
         <p:nvCxnSpPr>
-          <p:cNvPr id="67" name="Connector 66"/>
+          <p:cNvPr id="68" name="Connector 67"/>
           <p:cNvCxnSpPr/>
           <p:nvPr/>
         </p:nvCxnSpPr>
@@ -36451,7 +36502,7 @@
       </p:cxnSp>
       <p:cxnSp>
         <p:nvCxnSpPr>
-          <p:cNvPr id="68" name="Connector 67"/>
+          <p:cNvPr id="69" name="Connector 68"/>
           <p:cNvCxnSpPr/>
           <p:nvPr/>
         </p:nvCxnSpPr>
@@ -36487,7 +36538,7 @@
       </p:cxnSp>
       <p:cxnSp>
         <p:nvCxnSpPr>
-          <p:cNvPr id="69" name="Connector 68"/>
+          <p:cNvPr id="70" name="Connector 69"/>
           <p:cNvCxnSpPr/>
           <p:nvPr/>
         </p:nvCxnSpPr>
@@ -36523,7 +36574,7 @@
       </p:cxnSp>
       <p:cxnSp>
         <p:nvCxnSpPr>
-          <p:cNvPr id="70" name="Connector 69"/>
+          <p:cNvPr id="71" name="Connector 70"/>
           <p:cNvCxnSpPr/>
           <p:nvPr/>
         </p:nvCxnSpPr>
@@ -36559,7 +36610,7 @@
       </p:cxnSp>
       <p:cxnSp>
         <p:nvCxnSpPr>
-          <p:cNvPr id="71" name="Connector 70"/>
+          <p:cNvPr id="72" name="Connector 71"/>
           <p:cNvCxnSpPr/>
           <p:nvPr/>
         </p:nvCxnSpPr>
@@ -36595,7 +36646,7 @@
       </p:cxnSp>
       <p:cxnSp>
         <p:nvCxnSpPr>
-          <p:cNvPr id="72" name="Connector 71"/>
+          <p:cNvPr id="73" name="Connector 72"/>
           <p:cNvCxnSpPr/>
           <p:nvPr/>
         </p:nvCxnSpPr>
@@ -36631,7 +36682,7 @@
       </p:cxnSp>
       <p:cxnSp>
         <p:nvCxnSpPr>
-          <p:cNvPr id="73" name="Connector 72"/>
+          <p:cNvPr id="74" name="Connector 73"/>
           <p:cNvCxnSpPr/>
           <p:nvPr/>
         </p:nvCxnSpPr>
@@ -36639,41 +36690,6 @@
           <a:xfrm>
             <a:off x="4297680" y="4937760"/>
             <a:ext cx="0" cy="411480"/>
-          </a:xfrm>
-          <a:prstGeom prst="line">
-            <a:avLst/>
-          </a:prstGeom>
-          <a:ln w="28575">
-            <a:solidFill>
-              <a:srgbClr val="F5EFE9"/>
-            </a:solidFill>
-          </a:ln>
-        </p:spPr>
-        <p:style>
-          <a:lnRef idx="2">
-            <a:schemeClr val="accent1"/>
-          </a:lnRef>
-          <a:fillRef idx="0">
-            <a:schemeClr val="accent1"/>
-          </a:fillRef>
-          <a:effectRef idx="1">
-            <a:schemeClr val="accent1"/>
-          </a:effectRef>
-          <a:fontRef idx="minor">
-            <a:schemeClr val="tx1"/>
-          </a:fontRef>
-        </p:style>
-      </p:cxnSp>
-      <p:cxnSp>
-        <p:nvCxnSpPr>
-          <p:cNvPr id="74" name="Connector 73"/>
-          <p:cNvCxnSpPr/>
-          <p:nvPr/>
-        </p:nvCxnSpPr>
-        <p:spPr>
-          <a:xfrm>
-            <a:off x="4297680" y="5349240"/>
-            <a:ext cx="5486400" cy="0"/>
           </a:xfrm>
           <a:prstGeom prst="line">
             <a:avLst/>
@@ -36706,6 +36722,41 @@
           <p:nvPr/>
         </p:nvCxnSpPr>
         <p:spPr>
+          <a:xfrm>
+            <a:off x="4297680" y="5349240"/>
+            <a:ext cx="5486400" cy="0"/>
+          </a:xfrm>
+          <a:prstGeom prst="line">
+            <a:avLst/>
+          </a:prstGeom>
+          <a:ln w="28575">
+            <a:solidFill>
+              <a:srgbClr val="F5EFE9"/>
+            </a:solidFill>
+          </a:ln>
+        </p:spPr>
+        <p:style>
+          <a:lnRef idx="2">
+            <a:schemeClr val="accent1"/>
+          </a:lnRef>
+          <a:fillRef idx="0">
+            <a:schemeClr val="accent1"/>
+          </a:fillRef>
+          <a:effectRef idx="1">
+            <a:schemeClr val="accent1"/>
+          </a:effectRef>
+          <a:fontRef idx="minor">
+            <a:schemeClr val="tx1"/>
+          </a:fontRef>
+        </p:style>
+      </p:cxnSp>
+      <p:cxnSp>
+        <p:nvCxnSpPr>
+          <p:cNvPr id="76" name="Connector 75"/>
+          <p:cNvCxnSpPr/>
+          <p:nvPr/>
+        </p:nvCxnSpPr>
+        <p:spPr>
           <a:xfrm flipV="1">
             <a:off x="9784080" y="4937760"/>
             <a:ext cx="0" cy="411480"/>
@@ -36737,7 +36788,7 @@
       </p:cxnSp>
       <p:sp>
         <p:nvSpPr>
-          <p:cNvPr id="76" name="TextBox 75"/>
+          <p:cNvPr id="77" name="TextBox 76"/>
           <p:cNvSpPr txBox="1"/>
           <p:nvPr/>
         </p:nvSpPr>
@@ -36775,7 +36826,7 @@
       </p:sp>
       <p:cxnSp>
         <p:nvCxnSpPr>
-          <p:cNvPr id="77" name="Connector 76"/>
+          <p:cNvPr id="78" name="Connector 77"/>
           <p:cNvCxnSpPr/>
           <p:nvPr/>
         </p:nvCxnSpPr>
@@ -36811,7 +36862,7 @@
       </p:cxnSp>
       <p:cxnSp>
         <p:nvCxnSpPr>
-          <p:cNvPr id="78" name="Connector 77"/>
+          <p:cNvPr id="79" name="Connector 78"/>
           <p:cNvCxnSpPr/>
           <p:nvPr/>
         </p:nvCxnSpPr>
@@ -36847,7 +36898,7 @@
       </p:cxnSp>
       <p:cxnSp>
         <p:nvCxnSpPr>
-          <p:cNvPr id="79" name="Connector 78"/>
+          <p:cNvPr id="80" name="Connector 79"/>
           <p:cNvCxnSpPr/>
           <p:nvPr/>
         </p:nvCxnSpPr>
@@ -36883,7 +36934,7 @@
       </p:cxnSp>
       <p:cxnSp>
         <p:nvCxnSpPr>
-          <p:cNvPr id="80" name="Connector 79"/>
+          <p:cNvPr id="81" name="Connector 80"/>
           <p:cNvCxnSpPr/>
           <p:nvPr/>
         </p:nvCxnSpPr>
@@ -36919,7 +36970,7 @@
       </p:cxnSp>
       <p:cxnSp>
         <p:nvCxnSpPr>
-          <p:cNvPr id="81" name="Connector 80"/>
+          <p:cNvPr id="82" name="Connector 81"/>
           <p:cNvCxnSpPr/>
           <p:nvPr/>
         </p:nvCxnSpPr>
@@ -36927,41 +36978,6 @@
           <a:xfrm flipH="1">
             <a:off x="10332720" y="7452360"/>
             <a:ext cx="182880" cy="0"/>
-          </a:xfrm>
-          <a:prstGeom prst="line">
-            <a:avLst/>
-          </a:prstGeom>
-          <a:ln w="28575">
-            <a:solidFill>
-              <a:srgbClr val="F5EFE9"/>
-            </a:solidFill>
-          </a:ln>
-        </p:spPr>
-        <p:style>
-          <a:lnRef idx="2">
-            <a:schemeClr val="accent1"/>
-          </a:lnRef>
-          <a:fillRef idx="0">
-            <a:schemeClr val="accent1"/>
-          </a:fillRef>
-          <a:effectRef idx="1">
-            <a:schemeClr val="accent1"/>
-          </a:effectRef>
-          <a:fontRef idx="minor">
-            <a:schemeClr val="tx1"/>
-          </a:fontRef>
-        </p:style>
-      </p:cxnSp>
-      <p:cxnSp>
-        <p:nvCxnSpPr>
-          <p:cNvPr id="82" name="Connector 81"/>
-          <p:cNvCxnSpPr/>
-          <p:nvPr/>
-        </p:nvCxnSpPr>
-        <p:spPr>
-          <a:xfrm>
-            <a:off x="10332720" y="7452360"/>
-            <a:ext cx="0" cy="1280160"/>
           </a:xfrm>
           <a:prstGeom prst="line">
             <a:avLst/>
@@ -36995,8 +37011,8 @@
         </p:nvCxnSpPr>
         <p:spPr>
           <a:xfrm>
-            <a:off x="10332720" y="8732520"/>
-            <a:ext cx="886968" cy="0"/>
+            <a:off x="10332720" y="7452360"/>
+            <a:ext cx="0" cy="1280160"/>
           </a:xfrm>
           <a:prstGeom prst="line">
             <a:avLst/>
@@ -37030,6 +37046,41 @@
         </p:nvCxnSpPr>
         <p:spPr>
           <a:xfrm>
+            <a:off x="10332720" y="8732520"/>
+            <a:ext cx="886968" cy="0"/>
+          </a:xfrm>
+          <a:prstGeom prst="line">
+            <a:avLst/>
+          </a:prstGeom>
+          <a:ln w="28575">
+            <a:solidFill>
+              <a:srgbClr val="F5EFE9"/>
+            </a:solidFill>
+          </a:ln>
+        </p:spPr>
+        <p:style>
+          <a:lnRef idx="2">
+            <a:schemeClr val="accent1"/>
+          </a:lnRef>
+          <a:fillRef idx="0">
+            <a:schemeClr val="accent1"/>
+          </a:fillRef>
+          <a:effectRef idx="1">
+            <a:schemeClr val="accent1"/>
+          </a:effectRef>
+          <a:fontRef idx="minor">
+            <a:schemeClr val="tx1"/>
+          </a:fontRef>
+        </p:style>
+      </p:cxnSp>
+      <p:cxnSp>
+        <p:nvCxnSpPr>
+          <p:cNvPr id="85" name="Connector 84"/>
+          <p:cNvCxnSpPr/>
+          <p:nvPr/>
+        </p:nvCxnSpPr>
+        <p:spPr>
+          <a:xfrm>
             <a:off x="11219688" y="8732520"/>
             <a:ext cx="4572" cy="274320"/>
           </a:xfrm>
@@ -37060,7 +37111,7 @@
       </p:cxnSp>
       <p:cxnSp>
         <p:nvCxnSpPr>
-          <p:cNvPr id="85" name="Connector 84"/>
+          <p:cNvPr id="86" name="Connector 85"/>
           <p:cNvCxnSpPr/>
           <p:nvPr/>
         </p:nvCxnSpPr>
@@ -37068,41 +37119,6 @@
           <a:xfrm flipH="1">
             <a:off x="11996928" y="8229600"/>
             <a:ext cx="4572" cy="502920"/>
-          </a:xfrm>
-          <a:prstGeom prst="line">
-            <a:avLst/>
-          </a:prstGeom>
-          <a:ln w="28575">
-            <a:solidFill>
-              <a:srgbClr val="F5EFE9"/>
-            </a:solidFill>
-          </a:ln>
-        </p:spPr>
-        <p:style>
-          <a:lnRef idx="2">
-            <a:schemeClr val="accent1"/>
-          </a:lnRef>
-          <a:fillRef idx="0">
-            <a:schemeClr val="accent1"/>
-          </a:fillRef>
-          <a:effectRef idx="1">
-            <a:schemeClr val="accent1"/>
-          </a:effectRef>
-          <a:fontRef idx="minor">
-            <a:schemeClr val="tx1"/>
-          </a:fontRef>
-        </p:style>
-      </p:cxnSp>
-      <p:cxnSp>
-        <p:nvCxnSpPr>
-          <p:cNvPr id="86" name="Connector 85"/>
-          <p:cNvCxnSpPr/>
-          <p:nvPr/>
-        </p:nvCxnSpPr>
-        <p:spPr>
-          <a:xfrm>
-            <a:off x="11996928" y="8732520"/>
-            <a:ext cx="777240" cy="0"/>
           </a:xfrm>
           <a:prstGeom prst="line">
             <a:avLst/>
@@ -37136,6 +37152,41 @@
         </p:nvCxnSpPr>
         <p:spPr>
           <a:xfrm>
+            <a:off x="11996928" y="8732520"/>
+            <a:ext cx="777240" cy="0"/>
+          </a:xfrm>
+          <a:prstGeom prst="line">
+            <a:avLst/>
+          </a:prstGeom>
+          <a:ln w="28575">
+            <a:solidFill>
+              <a:srgbClr val="F5EFE9"/>
+            </a:solidFill>
+          </a:ln>
+        </p:spPr>
+        <p:style>
+          <a:lnRef idx="2">
+            <a:schemeClr val="accent1"/>
+          </a:lnRef>
+          <a:fillRef idx="0">
+            <a:schemeClr val="accent1"/>
+          </a:fillRef>
+          <a:effectRef idx="1">
+            <a:schemeClr val="accent1"/>
+          </a:effectRef>
+          <a:fontRef idx="minor">
+            <a:schemeClr val="tx1"/>
+          </a:fontRef>
+        </p:style>
+      </p:cxnSp>
+      <p:cxnSp>
+        <p:nvCxnSpPr>
+          <p:cNvPr id="88" name="Connector 87"/>
+          <p:cNvCxnSpPr/>
+          <p:nvPr/>
+        </p:nvCxnSpPr>
+        <p:spPr>
+          <a:xfrm>
             <a:off x="12774168" y="8732520"/>
             <a:ext cx="4572" cy="274320"/>
           </a:xfrm>
@@ -37166,7 +37217,7 @@
       </p:cxnSp>
       <p:cxnSp>
         <p:nvCxnSpPr>
-          <p:cNvPr id="88" name="Connector 87"/>
+          <p:cNvPr id="89" name="Connector 88"/>
           <p:cNvCxnSpPr/>
           <p:nvPr/>
         </p:nvCxnSpPr>
@@ -37174,41 +37225,6 @@
           <a:xfrm>
             <a:off x="15247620" y="8229600"/>
             <a:ext cx="0" cy="365760"/>
-          </a:xfrm>
-          <a:prstGeom prst="line">
-            <a:avLst/>
-          </a:prstGeom>
-          <a:ln w="28575">
-            <a:solidFill>
-              <a:srgbClr val="F5EFE9"/>
-            </a:solidFill>
-          </a:ln>
-        </p:spPr>
-        <p:style>
-          <a:lnRef idx="2">
-            <a:schemeClr val="accent1"/>
-          </a:lnRef>
-          <a:fillRef idx="0">
-            <a:schemeClr val="accent1"/>
-          </a:fillRef>
-          <a:effectRef idx="1">
-            <a:schemeClr val="accent1"/>
-          </a:effectRef>
-          <a:fontRef idx="minor">
-            <a:schemeClr val="tx1"/>
-          </a:fontRef>
-        </p:style>
-      </p:cxnSp>
-      <p:cxnSp>
-        <p:nvCxnSpPr>
-          <p:cNvPr id="89" name="Connector 88"/>
-          <p:cNvCxnSpPr/>
-          <p:nvPr/>
-        </p:nvCxnSpPr>
-        <p:spPr>
-          <a:xfrm flipH="1">
-            <a:off x="14447520" y="8595360"/>
-            <a:ext cx="800100" cy="0"/>
           </a:xfrm>
           <a:prstGeom prst="line">
             <a:avLst/>
@@ -37241,6 +37257,41 @@
           <p:nvPr/>
         </p:nvCxnSpPr>
         <p:spPr>
+          <a:xfrm flipH="1">
+            <a:off x="14447520" y="8595360"/>
+            <a:ext cx="800100" cy="0"/>
+          </a:xfrm>
+          <a:prstGeom prst="line">
+            <a:avLst/>
+          </a:prstGeom>
+          <a:ln w="28575">
+            <a:solidFill>
+              <a:srgbClr val="F5EFE9"/>
+            </a:solidFill>
+          </a:ln>
+        </p:spPr>
+        <p:style>
+          <a:lnRef idx="2">
+            <a:schemeClr val="accent1"/>
+          </a:lnRef>
+          <a:fillRef idx="0">
+            <a:schemeClr val="accent1"/>
+          </a:fillRef>
+          <a:effectRef idx="1">
+            <a:schemeClr val="accent1"/>
+          </a:effectRef>
+          <a:fontRef idx="minor">
+            <a:schemeClr val="tx1"/>
+          </a:fontRef>
+        </p:style>
+      </p:cxnSp>
+      <p:cxnSp>
+        <p:nvCxnSpPr>
+          <p:cNvPr id="91" name="Connector 90"/>
+          <p:cNvCxnSpPr/>
+          <p:nvPr/>
+        </p:nvCxnSpPr>
+        <p:spPr>
           <a:xfrm>
             <a:off x="14447520" y="8595360"/>
             <a:ext cx="0" cy="411480"/>
@@ -37272,7 +37323,7 @@
       </p:cxnSp>
       <p:cxnSp>
         <p:nvCxnSpPr>
-          <p:cNvPr id="91" name="Connector 90"/>
+          <p:cNvPr id="92" name="Connector 91"/>
           <p:cNvCxnSpPr/>
           <p:nvPr/>
         </p:nvCxnSpPr>
@@ -37280,41 +37331,6 @@
           <a:xfrm>
             <a:off x="15247620" y="8229600"/>
             <a:ext cx="0" cy="365760"/>
-          </a:xfrm>
-          <a:prstGeom prst="line">
-            <a:avLst/>
-          </a:prstGeom>
-          <a:ln w="28575">
-            <a:solidFill>
-              <a:srgbClr val="F5EFE9"/>
-            </a:solidFill>
-          </a:ln>
-        </p:spPr>
-        <p:style>
-          <a:lnRef idx="2">
-            <a:schemeClr val="accent1"/>
-          </a:lnRef>
-          <a:fillRef idx="0">
-            <a:schemeClr val="accent1"/>
-          </a:fillRef>
-          <a:effectRef idx="1">
-            <a:schemeClr val="accent1"/>
-          </a:effectRef>
-          <a:fontRef idx="minor">
-            <a:schemeClr val="tx1"/>
-          </a:fontRef>
-        </p:style>
-      </p:cxnSp>
-      <p:cxnSp>
-        <p:nvCxnSpPr>
-          <p:cNvPr id="92" name="Connector 91"/>
-          <p:cNvCxnSpPr/>
-          <p:nvPr/>
-        </p:nvCxnSpPr>
-        <p:spPr>
-          <a:xfrm>
-            <a:off x="15247620" y="8595360"/>
-            <a:ext cx="800100" cy="0"/>
           </a:xfrm>
           <a:prstGeom prst="line">
             <a:avLst/>
@@ -37348,6 +37364,41 @@
         </p:nvCxnSpPr>
         <p:spPr>
           <a:xfrm>
+            <a:off x="15247620" y="8595360"/>
+            <a:ext cx="800100" cy="0"/>
+          </a:xfrm>
+          <a:prstGeom prst="line">
+            <a:avLst/>
+          </a:prstGeom>
+          <a:ln w="28575">
+            <a:solidFill>
+              <a:srgbClr val="F5EFE9"/>
+            </a:solidFill>
+          </a:ln>
+        </p:spPr>
+        <p:style>
+          <a:lnRef idx="2">
+            <a:schemeClr val="accent1"/>
+          </a:lnRef>
+          <a:fillRef idx="0">
+            <a:schemeClr val="accent1"/>
+          </a:fillRef>
+          <a:effectRef idx="1">
+            <a:schemeClr val="accent1"/>
+          </a:effectRef>
+          <a:fontRef idx="minor">
+            <a:schemeClr val="tx1"/>
+          </a:fontRef>
+        </p:style>
+      </p:cxnSp>
+      <p:cxnSp>
+        <p:nvCxnSpPr>
+          <p:cNvPr id="94" name="Connector 93"/>
+          <p:cNvCxnSpPr/>
+          <p:nvPr/>
+        </p:nvCxnSpPr>
+        <p:spPr>
+          <a:xfrm>
             <a:off x="16047720" y="8595360"/>
             <a:ext cx="0" cy="411480"/>
           </a:xfrm>
@@ -37378,7 +37429,7 @@
       </p:cxnSp>
       <p:cxnSp>
         <p:nvCxnSpPr>
-          <p:cNvPr id="94" name="Connector 93"/>
+          <p:cNvPr id="95" name="Connector 94"/>
           <p:cNvCxnSpPr/>
           <p:nvPr/>
         </p:nvCxnSpPr>
@@ -37414,7 +37465,7 @@
       </p:cxnSp>
       <p:sp>
         <p:nvSpPr>
-          <p:cNvPr id="95" name="TextBox 94"/>
+          <p:cNvPr id="96" name="TextBox 95"/>
           <p:cNvSpPr txBox="1"/>
           <p:nvPr/>
         </p:nvSpPr>
@@ -37445,7 +37496,7 @@
                   <a:srgbClr val="F5EFE9"/>
                 </a:solidFill>
               </a:rPr>
-              <a:t>Cylinders are the tables the domains read; the boxes under the three view columns are the CMS views; orange diamonds are gates that stop the rollout. The loop under the second row is the twice-daily rolling refresh.</a:t>
+              <a:t>Every box in the map is one database object the domains read: seven rolling snapshot tables, the SA aged-balance table with its lookup seed, and eight CMS views. Orange diamonds are gates that stop the rollout; the loop under the second row is the twice-daily rolling refresh (3 months rebuilt, 24 kept; 6 months at CityCorp and Odessa).</a:t>
             </a:r>
           </a:p>
         </p:txBody>

</xml_diff>

<commit_message>
Gate formatting: narrower diamonds with half an inch to each stop box, yes and no labels beside the line (above a horizontal edge, right of a vertical one) in both builders, gate heights aligned to the boxes so the edges run straight
Co-Authored-By: Claude Fable 5.1 <noreply@anthropic.com>
</commit_message>
<xml_diff>
--- a/jaspersoft/docs/OriginBA_Automated_Deployment.pptx
+++ b/jaspersoft/docs/OriginBA_Automated_Deployment.pptx
@@ -14339,8 +14339,8 @@
         </p:nvSpPr>
         <p:spPr>
           <a:xfrm>
-            <a:off x="2185415" y="6080760"/>
-            <a:ext cx="1554480" cy="822960"/>
+            <a:off x="2276856" y="6080760"/>
+            <a:ext cx="1371600" cy="822960"/>
           </a:xfrm>
           <a:prstGeom prst="diamond">
             <a:avLst/>
@@ -14395,7 +14395,7 @@
         </p:nvSpPr>
         <p:spPr>
           <a:xfrm>
-            <a:off x="2057399" y="5952744"/>
+            <a:off x="2148840" y="5952744"/>
             <a:ext cx="310896" cy="310896"/>
           </a:xfrm>
           <a:prstGeom prst="ellipse">
@@ -14452,7 +14452,7 @@
         <p:spPr>
           <a:xfrm>
             <a:off x="923544" y="6286500"/>
-            <a:ext cx="1051560" cy="411480"/>
+            <a:ext cx="896112" cy="411480"/>
           </a:xfrm>
           <a:prstGeom prst="roundRect">
             <a:avLst>
@@ -14496,7 +14496,7 @@
                   <a:srgbClr val="0B3D7A"/>
                 </a:solidFill>
               </a:rPr>
-              <a:t>no: stop</a:t>
+              <a:t>stop</a:t>
             </a:r>
           </a:p>
         </p:txBody>
@@ -14896,8 +14896,8 @@
         </p:nvSpPr>
         <p:spPr>
           <a:xfrm>
-            <a:off x="6922008" y="5394960"/>
-            <a:ext cx="1554480" cy="822960"/>
+            <a:off x="7013448" y="5394960"/>
+            <a:ext cx="1371600" cy="822960"/>
           </a:xfrm>
           <a:prstGeom prst="diamond">
             <a:avLst/>
@@ -14952,7 +14952,7 @@
         </p:nvSpPr>
         <p:spPr>
           <a:xfrm>
-            <a:off x="6793992" y="5266944"/>
+            <a:off x="6885432" y="5266944"/>
             <a:ext cx="310896" cy="310896"/>
           </a:xfrm>
           <a:prstGeom prst="ellipse">
@@ -15008,8 +15008,8 @@
         </p:nvSpPr>
         <p:spPr>
           <a:xfrm>
-            <a:off x="8549640" y="5600700"/>
-            <a:ext cx="1188720" cy="411480"/>
+            <a:off x="8842248" y="5600700"/>
+            <a:ext cx="896112" cy="411480"/>
           </a:xfrm>
           <a:prstGeom prst="roundRect">
             <a:avLst>
@@ -15053,7 +15053,7 @@
                   <a:srgbClr val="0B3D7A"/>
                 </a:solidFill>
               </a:rPr>
-              <a:t>no: stop</a:t>
+              <a:t>stop</a:t>
             </a:r>
           </a:p>
         </p:txBody>
@@ -15511,8 +15511,8 @@
         </p:nvSpPr>
         <p:spPr>
           <a:xfrm>
-            <a:off x="11247119" y="5212080"/>
-            <a:ext cx="2377440" cy="960120"/>
+            <a:off x="11750040" y="5212080"/>
+            <a:ext cx="1371600" cy="822960"/>
           </a:xfrm>
           <a:prstGeom prst="diamond">
             <a:avLst/>
@@ -15549,12 +15549,12 @@
               </a:spcAft>
             </a:pPr>
             <a:r>
-              <a:rPr sz="1000" b="1">
+              <a:rPr sz="1100" b="1">
                 <a:solidFill>
                   <a:srgbClr val="0B3D7A"/>
                 </a:solidFill>
               </a:rPr>
-              <a:t>verified? no source strings, references exist, fields resolve</a:t>
+              <a:t>package verified?</a:t>
             </a:r>
           </a:p>
         </p:txBody>
@@ -15567,7 +15567,7 @@
         </p:nvSpPr>
         <p:spPr>
           <a:xfrm>
-            <a:off x="11119103" y="5084064"/>
+            <a:off x="11622024" y="5084064"/>
             <a:ext cx="310896" cy="310896"/>
           </a:xfrm>
           <a:prstGeom prst="ellipse">
@@ -15623,8 +15623,8 @@
         </p:nvSpPr>
         <p:spPr>
           <a:xfrm>
-            <a:off x="13697711" y="5486400"/>
-            <a:ext cx="777240" cy="411480"/>
+            <a:off x="13578840" y="5417820"/>
+            <a:ext cx="896112" cy="411480"/>
           </a:xfrm>
           <a:prstGeom prst="roundRect">
             <a:avLst>
@@ -15668,7 +15668,7 @@
                   <a:srgbClr val="0B3D7A"/>
                 </a:solidFill>
               </a:rPr>
-              <a:t>no: stop</a:t>
+              <a:t>stop</a:t>
             </a:r>
           </a:p>
         </p:txBody>
@@ -15681,7 +15681,7 @@
         </p:nvSpPr>
         <p:spPr>
           <a:xfrm>
-            <a:off x="10378440" y="6309360"/>
+            <a:off x="10378440" y="6217920"/>
             <a:ext cx="4114800" cy="731520"/>
           </a:xfrm>
           <a:prstGeom prst="roundRect">
@@ -15754,7 +15754,7 @@
         </p:nvSpPr>
         <p:spPr>
           <a:xfrm>
-            <a:off x="10250424" y="6181344"/>
+            <a:off x="10250424" y="6089904"/>
             <a:ext cx="310896" cy="310896"/>
           </a:xfrm>
           <a:prstGeom prst="ellipse">
@@ -15810,7 +15810,7 @@
         </p:nvSpPr>
         <p:spPr>
           <a:xfrm>
-            <a:off x="10378440" y="7178040"/>
+            <a:off x="10378440" y="7086600"/>
             <a:ext cx="4114800" cy="914400"/>
           </a:xfrm>
           <a:prstGeom prst="roundRect">
@@ -15883,7 +15883,7 @@
         </p:nvSpPr>
         <p:spPr>
           <a:xfrm>
-            <a:off x="10250424" y="7050024"/>
+            <a:off x="10250424" y="6958584"/>
             <a:ext cx="310896" cy="310896"/>
           </a:xfrm>
           <a:prstGeom prst="ellipse">
@@ -16255,8 +16255,8 @@
         </p:nvSpPr>
         <p:spPr>
           <a:xfrm>
-            <a:off x="16395192" y="5074920"/>
-            <a:ext cx="1554480" cy="822960"/>
+            <a:off x="16486632" y="5074920"/>
+            <a:ext cx="1371600" cy="822960"/>
           </a:xfrm>
           <a:prstGeom prst="diamond">
             <a:avLst/>
@@ -16311,7 +16311,7 @@
         </p:nvSpPr>
         <p:spPr>
           <a:xfrm>
-            <a:off x="16267176" y="4946904"/>
+            <a:off x="16358616" y="4946904"/>
             <a:ext cx="310896" cy="310896"/>
           </a:xfrm>
           <a:prstGeom prst="ellipse">
@@ -16367,8 +16367,8 @@
         </p:nvSpPr>
         <p:spPr>
           <a:xfrm>
-            <a:off x="18022824" y="5280660"/>
-            <a:ext cx="1188720" cy="411480"/>
+            <a:off x="18315432" y="5280660"/>
+            <a:ext cx="896112" cy="411480"/>
           </a:xfrm>
           <a:prstGeom prst="roundRect">
             <a:avLst>
@@ -16412,7 +16412,7 @@
                   <a:srgbClr val="0B3D7A"/>
                 </a:solidFill>
               </a:rPr>
-              <a:t>no: stop</a:t>
+              <a:t>stop</a:t>
             </a:r>
           </a:p>
         </p:txBody>
@@ -17048,8 +17048,8 @@
         </p:nvCxnSpPr>
         <p:spPr>
           <a:xfrm flipH="1">
-            <a:off x="1975104" y="6492240"/>
-            <a:ext cx="210311" cy="0"/>
+            <a:off x="1819656" y="6492240"/>
+            <a:ext cx="457200" cy="0"/>
           </a:xfrm>
           <a:prstGeom prst="line">
             <a:avLst/>
@@ -17084,8 +17084,8 @@
         </p:nvSpPr>
         <p:spPr>
           <a:xfrm>
-            <a:off x="2171700" y="6108192"/>
-            <a:ext cx="2926080" cy="365760"/>
+            <a:off x="1499616" y="6181344"/>
+            <a:ext cx="1097280" cy="274320"/>
           </a:xfrm>
           <a:prstGeom prst="rect">
             <a:avLst/>
@@ -17098,7 +17098,7 @@
           </a:bodyPr>
           <a:lstStyle/>
           <a:p>
-            <a:pPr algn="l">
+            <a:pPr algn="ctr">
               <a:spcAft>
                 <a:spcPts val="600"/>
               </a:spcAft>
@@ -17122,8 +17122,8 @@
         </p:nvCxnSpPr>
         <p:spPr>
           <a:xfrm>
-            <a:off x="3739896" y="6492240"/>
-            <a:ext cx="1591056" cy="0"/>
+            <a:off x="3648456" y="6492240"/>
+            <a:ext cx="1682496" cy="0"/>
           </a:xfrm>
           <a:prstGeom prst="line">
             <a:avLst/>
@@ -17220,9 +17220,47 @@
           </a:fontRef>
         </p:style>
       </p:cxnSp>
+      <p:sp>
+        <p:nvSpPr>
+          <p:cNvPr id="71" name="TextBox 70"/>
+          <p:cNvSpPr txBox="1"/>
+          <p:nvPr/>
+        </p:nvSpPr>
+        <p:spPr>
+          <a:xfrm>
+            <a:off x="4023360" y="6144768"/>
+            <a:ext cx="914400" cy="365760"/>
+          </a:xfrm>
+          <a:prstGeom prst="rect">
+            <a:avLst/>
+          </a:prstGeom>
+          <a:noFill/>
+        </p:spPr>
+        <p:txBody>
+          <a:bodyPr wrap="square" anchor="b" lIns="0" rIns="0" tIns="54864" bIns="54864">
+            <a:spAutoFit/>
+          </a:bodyPr>
+          <a:lstStyle/>
+          <a:p>
+            <a:pPr algn="l">
+              <a:spcAft>
+                <a:spcPts val="600"/>
+              </a:spcAft>
+            </a:pPr>
+            <a:r>
+              <a:rPr sz="1100" b="1">
+                <a:solidFill>
+                  <a:srgbClr val="F5EFE9"/>
+                </a:solidFill>
+              </a:rPr>
+              <a:t>yes</a:t>
+            </a:r>
+          </a:p>
+        </p:txBody>
+      </p:sp>
       <p:cxnSp>
         <p:nvCxnSpPr>
-          <p:cNvPr id="71" name="Connector 70"/>
+          <p:cNvPr id="72" name="Connector 71"/>
           <p:cNvCxnSpPr/>
           <p:nvPr/>
         </p:nvCxnSpPr>
@@ -17258,7 +17296,7 @@
       </p:cxnSp>
       <p:cxnSp>
         <p:nvCxnSpPr>
-          <p:cNvPr id="72" name="Connector 71"/>
+          <p:cNvPr id="73" name="Connector 72"/>
           <p:cNvCxnSpPr/>
           <p:nvPr/>
         </p:nvCxnSpPr>
@@ -17294,7 +17332,7 @@
       </p:cxnSp>
       <p:cxnSp>
         <p:nvCxnSpPr>
-          <p:cNvPr id="73" name="Connector 72"/>
+          <p:cNvPr id="74" name="Connector 73"/>
           <p:cNvCxnSpPr/>
           <p:nvPr/>
         </p:nvCxnSpPr>
@@ -17330,14 +17368,14 @@
       </p:cxnSp>
       <p:cxnSp>
         <p:nvCxnSpPr>
-          <p:cNvPr id="74" name="Connector 73"/>
+          <p:cNvPr id="75" name="Connector 74"/>
           <p:cNvCxnSpPr/>
           <p:nvPr/>
         </p:nvCxnSpPr>
         <p:spPr>
           <a:xfrm>
-            <a:off x="8476488" y="5806440"/>
-            <a:ext cx="73152" cy="0"/>
+            <a:off x="8385048" y="5806440"/>
+            <a:ext cx="457200" cy="0"/>
           </a:xfrm>
           <a:prstGeom prst="line">
             <a:avLst/>
@@ -17366,14 +17404,14 @@
       </p:cxnSp>
       <p:sp>
         <p:nvSpPr>
-          <p:cNvPr id="75" name="TextBox 74"/>
+          <p:cNvPr id="76" name="TextBox 75"/>
           <p:cNvSpPr txBox="1"/>
           <p:nvPr/>
         </p:nvSpPr>
         <p:spPr>
           <a:xfrm>
-            <a:off x="8604503" y="5422392"/>
-            <a:ext cx="2926080" cy="365760"/>
+            <a:off x="8065008" y="5495544"/>
+            <a:ext cx="1097280" cy="274320"/>
           </a:xfrm>
           <a:prstGeom prst="rect">
             <a:avLst/>
@@ -17386,7 +17424,7 @@
           </a:bodyPr>
           <a:lstStyle/>
           <a:p>
-            <a:pPr algn="l">
+            <a:pPr algn="ctr">
               <a:spcAft>
                 <a:spcPts val="600"/>
               </a:spcAft>
@@ -17404,7 +17442,7 @@
       </p:sp>
       <p:cxnSp>
         <p:nvCxnSpPr>
-          <p:cNvPr id="76" name="Connector 75"/>
+          <p:cNvPr id="77" name="Connector 76"/>
           <p:cNvCxnSpPr/>
           <p:nvPr/>
         </p:nvCxnSpPr>
@@ -17438,9 +17476,47 @@
           </a:fontRef>
         </p:style>
       </p:cxnSp>
+      <p:sp>
+        <p:nvSpPr>
+          <p:cNvPr id="78" name="TextBox 77"/>
+          <p:cNvSpPr txBox="1"/>
+          <p:nvPr/>
+        </p:nvSpPr>
+        <p:spPr>
+          <a:xfrm>
+            <a:off x="7763256" y="6172200"/>
+            <a:ext cx="1097280" cy="274320"/>
+          </a:xfrm>
+          <a:prstGeom prst="rect">
+            <a:avLst/>
+          </a:prstGeom>
+          <a:noFill/>
+        </p:spPr>
+        <p:txBody>
+          <a:bodyPr wrap="square" anchor="ctr" lIns="0" rIns="0" tIns="54864" bIns="54864">
+            <a:spAutoFit/>
+          </a:bodyPr>
+          <a:lstStyle/>
+          <a:p>
+            <a:pPr algn="l">
+              <a:spcAft>
+                <a:spcPts val="600"/>
+              </a:spcAft>
+            </a:pPr>
+            <a:r>
+              <a:rPr sz="1100" b="1">
+                <a:solidFill>
+                  <a:srgbClr val="F5EFE9"/>
+                </a:solidFill>
+              </a:rPr>
+              <a:t>yes</a:t>
+            </a:r>
+          </a:p>
+        </p:txBody>
+      </p:sp>
       <p:cxnSp>
         <p:nvCxnSpPr>
-          <p:cNvPr id="77" name="Connector 76"/>
+          <p:cNvPr id="79" name="Connector 78"/>
           <p:cNvCxnSpPr/>
           <p:nvPr/>
         </p:nvCxnSpPr>
@@ -17475,7 +17551,7 @@
       </p:cxnSp>
       <p:cxnSp>
         <p:nvCxnSpPr>
-          <p:cNvPr id="78" name="Connector 77"/>
+          <p:cNvPr id="80" name="Connector 79"/>
           <p:cNvCxnSpPr/>
           <p:nvPr/>
         </p:nvCxnSpPr>
@@ -17510,7 +17586,7 @@
       </p:cxnSp>
       <p:cxnSp>
         <p:nvCxnSpPr>
-          <p:cNvPr id="79" name="Connector 78"/>
+          <p:cNvPr id="81" name="Connector 80"/>
           <p:cNvCxnSpPr/>
           <p:nvPr/>
         </p:nvCxnSpPr>
@@ -17546,7 +17622,7 @@
       </p:cxnSp>
       <p:cxnSp>
         <p:nvCxnSpPr>
-          <p:cNvPr id="80" name="Connector 79"/>
+          <p:cNvPr id="82" name="Connector 81"/>
           <p:cNvCxnSpPr/>
           <p:nvPr/>
         </p:nvCxnSpPr>
@@ -17582,7 +17658,7 @@
       </p:cxnSp>
       <p:cxnSp>
         <p:nvCxnSpPr>
-          <p:cNvPr id="81" name="Connector 80"/>
+          <p:cNvPr id="83" name="Connector 82"/>
           <p:cNvCxnSpPr/>
           <p:nvPr/>
         </p:nvCxnSpPr>
@@ -17618,7 +17694,7 @@
       </p:cxnSp>
       <p:cxnSp>
         <p:nvCxnSpPr>
-          <p:cNvPr id="82" name="Connector 81"/>
+          <p:cNvPr id="84" name="Connector 83"/>
           <p:cNvCxnSpPr/>
           <p:nvPr/>
         </p:nvCxnSpPr>
@@ -17654,14 +17730,14 @@
       </p:cxnSp>
       <p:cxnSp>
         <p:nvCxnSpPr>
-          <p:cNvPr id="83" name="Connector 82"/>
+          <p:cNvPr id="85" name="Connector 84"/>
           <p:cNvCxnSpPr/>
           <p:nvPr/>
         </p:nvCxnSpPr>
         <p:spPr>
-          <a:xfrm>
-            <a:off x="13624559" y="5692140"/>
-            <a:ext cx="73152" cy="0"/>
+          <a:xfrm flipV="1">
+            <a:off x="13121640" y="5623559"/>
+            <a:ext cx="457200" cy="1"/>
           </a:xfrm>
           <a:prstGeom prst="line">
             <a:avLst/>
@@ -17690,14 +17766,14 @@
       </p:cxnSp>
       <p:sp>
         <p:nvSpPr>
-          <p:cNvPr id="84" name="TextBox 83"/>
+          <p:cNvPr id="86" name="TextBox 85"/>
           <p:cNvSpPr txBox="1"/>
           <p:nvPr/>
         </p:nvSpPr>
         <p:spPr>
           <a:xfrm>
-            <a:off x="13752575" y="5308092"/>
-            <a:ext cx="2926080" cy="365760"/>
+            <a:off x="12801600" y="5312664"/>
+            <a:ext cx="1097280" cy="274320"/>
           </a:xfrm>
           <a:prstGeom prst="rect">
             <a:avLst/>
@@ -17710,7 +17786,7 @@
           </a:bodyPr>
           <a:lstStyle/>
           <a:p>
-            <a:pPr algn="l">
+            <a:pPr algn="ctr">
               <a:spcAft>
                 <a:spcPts val="600"/>
               </a:spcAft>
@@ -17728,14 +17804,14 @@
       </p:sp>
       <p:cxnSp>
         <p:nvCxnSpPr>
-          <p:cNvPr id="85" name="Connector 84"/>
+          <p:cNvPr id="87" name="Connector 86"/>
           <p:cNvCxnSpPr/>
           <p:nvPr/>
         </p:nvCxnSpPr>
         <p:spPr>
           <a:xfrm>
-            <a:off x="12435840" y="6172200"/>
-            <a:ext cx="0" cy="137160"/>
+            <a:off x="12435840" y="6035040"/>
+            <a:ext cx="0" cy="182880"/>
           </a:xfrm>
           <a:prstGeom prst="line">
             <a:avLst/>
@@ -17762,15 +17838,53 @@
           </a:fontRef>
         </p:style>
       </p:cxnSp>
+      <p:sp>
+        <p:nvSpPr>
+          <p:cNvPr id="88" name="TextBox 87"/>
+          <p:cNvSpPr txBox="1"/>
+          <p:nvPr/>
+        </p:nvSpPr>
+        <p:spPr>
+          <a:xfrm>
+            <a:off x="12499848" y="5989320"/>
+            <a:ext cx="1097280" cy="274320"/>
+          </a:xfrm>
+          <a:prstGeom prst="rect">
+            <a:avLst/>
+          </a:prstGeom>
+          <a:noFill/>
+        </p:spPr>
+        <p:txBody>
+          <a:bodyPr wrap="square" anchor="ctr" lIns="0" rIns="0" tIns="54864" bIns="54864">
+            <a:spAutoFit/>
+          </a:bodyPr>
+          <a:lstStyle/>
+          <a:p>
+            <a:pPr algn="l">
+              <a:spcAft>
+                <a:spcPts val="600"/>
+              </a:spcAft>
+            </a:pPr>
+            <a:r>
+              <a:rPr sz="1100" b="1">
+                <a:solidFill>
+                  <a:srgbClr val="F5EFE9"/>
+                </a:solidFill>
+              </a:rPr>
+              <a:t>yes</a:t>
+            </a:r>
+          </a:p>
+        </p:txBody>
+      </p:sp>
       <p:cxnSp>
         <p:nvCxnSpPr>
-          <p:cNvPr id="86" name="Connector 85"/>
+          <p:cNvPr id="89" name="Connector 88"/>
           <p:cNvCxnSpPr/>
           <p:nvPr/>
         </p:nvCxnSpPr>
         <p:spPr>
           <a:xfrm>
-            <a:off x="12435840" y="7040880"/>
+            <a:off x="12435840" y="6949440"/>
             <a:ext cx="0" cy="137160"/>
           </a:xfrm>
           <a:prstGeom prst="line">
@@ -17800,13 +17914,13 @@
       </p:cxnSp>
       <p:cxnSp>
         <p:nvCxnSpPr>
-          <p:cNvPr id="87" name="Connector 86"/>
+          <p:cNvPr id="90" name="Connector 89"/>
           <p:cNvCxnSpPr/>
           <p:nvPr/>
         </p:nvCxnSpPr>
         <p:spPr>
           <a:xfrm>
-            <a:off x="14493240" y="7635240"/>
+            <a:off x="14493240" y="7543800"/>
             <a:ext cx="310896" cy="0"/>
           </a:xfrm>
           <a:prstGeom prst="line">
@@ -17835,14 +17949,14 @@
       </p:cxnSp>
       <p:cxnSp>
         <p:nvCxnSpPr>
-          <p:cNvPr id="88" name="Connector 87"/>
+          <p:cNvPr id="91" name="Connector 90"/>
           <p:cNvCxnSpPr/>
           <p:nvPr/>
         </p:nvCxnSpPr>
         <p:spPr>
           <a:xfrm flipV="1">
             <a:off x="14804136" y="2743200"/>
-            <a:ext cx="0" cy="4892040"/>
+            <a:ext cx="0" cy="4800600"/>
           </a:xfrm>
           <a:prstGeom prst="line">
             <a:avLst/>
@@ -17870,7 +17984,7 @@
       </p:cxnSp>
       <p:cxnSp>
         <p:nvCxnSpPr>
-          <p:cNvPr id="89" name="Connector 88"/>
+          <p:cNvPr id="92" name="Connector 91"/>
           <p:cNvCxnSpPr/>
           <p:nvPr/>
         </p:nvCxnSpPr>
@@ -17906,7 +18020,7 @@
       </p:cxnSp>
       <p:cxnSp>
         <p:nvCxnSpPr>
-          <p:cNvPr id="90" name="Connector 89"/>
+          <p:cNvPr id="93" name="Connector 92"/>
           <p:cNvCxnSpPr/>
           <p:nvPr/>
         </p:nvCxnSpPr>
@@ -17942,7 +18056,7 @@
       </p:cxnSp>
       <p:cxnSp>
         <p:nvCxnSpPr>
-          <p:cNvPr id="91" name="Connector 90"/>
+          <p:cNvPr id="94" name="Connector 93"/>
           <p:cNvCxnSpPr/>
           <p:nvPr/>
         </p:nvCxnSpPr>
@@ -17978,7 +18092,7 @@
       </p:cxnSp>
       <p:cxnSp>
         <p:nvCxnSpPr>
-          <p:cNvPr id="92" name="Connector 91"/>
+          <p:cNvPr id="95" name="Connector 94"/>
           <p:cNvCxnSpPr/>
           <p:nvPr/>
         </p:nvCxnSpPr>
@@ -18014,14 +18128,14 @@
       </p:cxnSp>
       <p:cxnSp>
         <p:nvCxnSpPr>
-          <p:cNvPr id="93" name="Connector 92"/>
+          <p:cNvPr id="96" name="Connector 95"/>
           <p:cNvCxnSpPr/>
           <p:nvPr/>
         </p:nvCxnSpPr>
         <p:spPr>
           <a:xfrm>
-            <a:off x="17949672" y="5486400"/>
-            <a:ext cx="73152" cy="0"/>
+            <a:off x="17858232" y="5486400"/>
+            <a:ext cx="457200" cy="0"/>
           </a:xfrm>
           <a:prstGeom prst="line">
             <a:avLst/>
@@ -18050,14 +18164,14 @@
       </p:cxnSp>
       <p:sp>
         <p:nvSpPr>
-          <p:cNvPr id="94" name="TextBox 93"/>
+          <p:cNvPr id="97" name="TextBox 96"/>
           <p:cNvSpPr txBox="1"/>
           <p:nvPr/>
         </p:nvSpPr>
         <p:spPr>
           <a:xfrm>
-            <a:off x="18077688" y="5102352"/>
-            <a:ext cx="2926080" cy="365760"/>
+            <a:off x="17538192" y="5175504"/>
+            <a:ext cx="1097280" cy="274320"/>
           </a:xfrm>
           <a:prstGeom prst="rect">
             <a:avLst/>
@@ -18070,7 +18184,7 @@
           </a:bodyPr>
           <a:lstStyle/>
           <a:p>
-            <a:pPr algn="l">
+            <a:pPr algn="ctr">
               <a:spcAft>
                 <a:spcPts val="600"/>
               </a:spcAft>
@@ -18088,7 +18202,7 @@
       </p:sp>
       <p:cxnSp>
         <p:nvCxnSpPr>
-          <p:cNvPr id="95" name="Connector 94"/>
+          <p:cNvPr id="98" name="Connector 97"/>
           <p:cNvCxnSpPr/>
           <p:nvPr/>
         </p:nvCxnSpPr>
@@ -18122,9 +18236,47 @@
           </a:fontRef>
         </p:style>
       </p:cxnSp>
+      <p:sp>
+        <p:nvSpPr>
+          <p:cNvPr id="99" name="TextBox 98"/>
+          <p:cNvSpPr txBox="1"/>
+          <p:nvPr/>
+        </p:nvSpPr>
+        <p:spPr>
+          <a:xfrm>
+            <a:off x="17236440" y="5829300"/>
+            <a:ext cx="1097280" cy="274320"/>
+          </a:xfrm>
+          <a:prstGeom prst="rect">
+            <a:avLst/>
+          </a:prstGeom>
+          <a:noFill/>
+        </p:spPr>
+        <p:txBody>
+          <a:bodyPr wrap="square" anchor="ctr" lIns="0" rIns="0" tIns="54864" bIns="54864">
+            <a:spAutoFit/>
+          </a:bodyPr>
+          <a:lstStyle/>
+          <a:p>
+            <a:pPr algn="l">
+              <a:spcAft>
+                <a:spcPts val="600"/>
+              </a:spcAft>
+            </a:pPr>
+            <a:r>
+              <a:rPr sz="1100" b="1">
+                <a:solidFill>
+                  <a:srgbClr val="F5EFE9"/>
+                </a:solidFill>
+              </a:rPr>
+              <a:t>yes</a:t>
+            </a:r>
+          </a:p>
+        </p:txBody>
+      </p:sp>
       <p:cxnSp>
         <p:nvCxnSpPr>
-          <p:cNvPr id="96" name="Connector 95"/>
+          <p:cNvPr id="100" name="Connector 99"/>
           <p:cNvCxnSpPr/>
           <p:nvPr/>
         </p:nvCxnSpPr>
@@ -18160,7 +18312,7 @@
       </p:cxnSp>
       <p:cxnSp>
         <p:nvCxnSpPr>
-          <p:cNvPr id="97" name="Connector 96"/>
+          <p:cNvPr id="101" name="Connector 100"/>
           <p:cNvCxnSpPr/>
           <p:nvPr/>
         </p:nvCxnSpPr>
@@ -18195,7 +18347,7 @@
       </p:cxnSp>
       <p:cxnSp>
         <p:nvCxnSpPr>
-          <p:cNvPr id="98" name="Connector 97"/>
+          <p:cNvPr id="102" name="Connector 101"/>
           <p:cNvCxnSpPr/>
           <p:nvPr/>
         </p:nvCxnSpPr>
@@ -18230,7 +18382,7 @@
       </p:cxnSp>
       <p:cxnSp>
         <p:nvCxnSpPr>
-          <p:cNvPr id="99" name="Connector 98"/>
+          <p:cNvPr id="103" name="Connector 102"/>
           <p:cNvCxnSpPr/>
           <p:nvPr/>
         </p:nvCxnSpPr>
@@ -18266,7 +18418,7 @@
       </p:cxnSp>
       <p:cxnSp>
         <p:nvCxnSpPr>
-          <p:cNvPr id="100" name="Connector 99"/>
+          <p:cNvPr id="104" name="Connector 103"/>
           <p:cNvCxnSpPr/>
           <p:nvPr/>
         </p:nvCxnSpPr>
@@ -18301,7 +18453,7 @@
       </p:cxnSp>
       <p:cxnSp>
         <p:nvCxnSpPr>
-          <p:cNvPr id="101" name="Connector 100"/>
+          <p:cNvPr id="105" name="Connector 104"/>
           <p:cNvCxnSpPr/>
           <p:nvPr/>
         </p:nvCxnSpPr>
@@ -18336,7 +18488,7 @@
       </p:cxnSp>
       <p:cxnSp>
         <p:nvCxnSpPr>
-          <p:cNvPr id="102" name="Connector 101"/>
+          <p:cNvPr id="106" name="Connector 105"/>
           <p:cNvCxnSpPr/>
           <p:nvPr/>
         </p:nvCxnSpPr>
@@ -18371,7 +18523,7 @@
       </p:cxnSp>
       <p:cxnSp>
         <p:nvCxnSpPr>
-          <p:cNvPr id="103" name="Connector 102"/>
+          <p:cNvPr id="107" name="Connector 106"/>
           <p:cNvCxnSpPr/>
           <p:nvPr/>
         </p:nvCxnSpPr>
@@ -18407,7 +18559,7 @@
       </p:cxnSp>
       <p:sp>
         <p:nvSpPr>
-          <p:cNvPr id="104" name="TextBox 103"/>
+          <p:cNvPr id="108" name="TextBox 107"/>
           <p:cNvSpPr txBox="1"/>
           <p:nvPr/>
         </p:nvSpPr>
@@ -18438,7 +18590,7 @@
                   <a:srgbClr val="F5EFE9"/>
                 </a:solidFill>
               </a:rPr>
-              <a:t>Orange diamonds are gates: a 'no' stops the run and names the rollback. Numbers are the order of one full promotion. The Workstreams tree is never moved; the offering is a curated copy promoted org by org.</a:t>
+              <a:t>Orange diamonds are gates: yes continues, no stops the run and names the rollback. Numbers are the order of one full promotion. The Workstreams tree is never moved; the offering is a curated copy promoted org by org.</a:t>
             </a:r>
           </a:p>
         </p:txBody>
@@ -36530,8 +36682,8 @@
         </p:nvSpPr>
         <p:spPr>
           <a:xfrm>
-            <a:off x="17099280" y="4023360"/>
-            <a:ext cx="2103120" cy="960120"/>
+            <a:off x="17099280" y="4069080"/>
+            <a:ext cx="2103120" cy="868680"/>
           </a:xfrm>
           <a:prstGeom prst="diamond">
             <a:avLst/>
@@ -36586,7 +36738,7 @@
         </p:nvSpPr>
         <p:spPr>
           <a:xfrm>
-            <a:off x="16971264" y="3895344"/>
+            <a:off x="16971264" y="3941064"/>
             <a:ext cx="310896" cy="310896"/>
           </a:xfrm>
           <a:prstGeom prst="ellipse">
@@ -36642,8 +36794,8 @@
         </p:nvSpPr>
         <p:spPr>
           <a:xfrm>
-            <a:off x="17282160" y="5120640"/>
-            <a:ext cx="1737360" cy="411480"/>
+            <a:off x="17282160" y="5257800"/>
+            <a:ext cx="1737360" cy="384048"/>
           </a:xfrm>
           <a:prstGeom prst="roundRect">
             <a:avLst>
@@ -36687,7 +36839,7 @@
                   <a:srgbClr val="0B3D7A"/>
                 </a:solidFill>
               </a:rPr>
-              <a:t>no: stop, fix, re-run</a:t>
+              <a:t>stop, fix, re-run</a:t>
             </a:r>
           </a:p>
         </p:txBody>
@@ -36700,8 +36852,8 @@
         </p:nvSpPr>
         <p:spPr>
           <a:xfrm>
-            <a:off x="14264640" y="4023360"/>
-            <a:ext cx="2377440" cy="960120"/>
+            <a:off x="14264640" y="4069080"/>
+            <a:ext cx="2377440" cy="868680"/>
           </a:xfrm>
           <a:prstGeom prst="diamond">
             <a:avLst/>
@@ -36756,7 +36908,7 @@
         </p:nvSpPr>
         <p:spPr>
           <a:xfrm>
-            <a:off x="14136624" y="3895344"/>
+            <a:off x="14136624" y="3941064"/>
             <a:ext cx="310896" cy="310896"/>
           </a:xfrm>
           <a:prstGeom prst="ellipse">
@@ -36812,8 +36964,8 @@
         </p:nvSpPr>
         <p:spPr>
           <a:xfrm>
-            <a:off x="14493240" y="5120640"/>
-            <a:ext cx="1920240" cy="411480"/>
+            <a:off x="14493240" y="5257800"/>
+            <a:ext cx="1920240" cy="384048"/>
           </a:xfrm>
           <a:prstGeom prst="roundRect">
             <a:avLst>
@@ -36857,7 +37009,7 @@
                   <a:srgbClr val="0B3D7A"/>
                 </a:solidFill>
               </a:rPr>
-              <a:t>no: stop, fix, re-run</a:t>
+              <a:t>stop, fix, re-run</a:t>
             </a:r>
           </a:p>
         </p:txBody>
@@ -36870,8 +37022,8 @@
         </p:nvSpPr>
         <p:spPr>
           <a:xfrm>
-            <a:off x="11612880" y="4114800"/>
-            <a:ext cx="2194560" cy="777240"/>
+            <a:off x="11612880" y="4069080"/>
+            <a:ext cx="2194560" cy="868680"/>
           </a:xfrm>
           <a:prstGeom prst="roundRect">
             <a:avLst>
@@ -36943,7 +37095,7 @@
         </p:nvSpPr>
         <p:spPr>
           <a:xfrm>
-            <a:off x="11484863" y="3986784"/>
+            <a:off x="11484863" y="3941064"/>
             <a:ext cx="310896" cy="310896"/>
           </a:xfrm>
           <a:prstGeom prst="ellipse">
@@ -37128,8 +37280,8 @@
         </p:nvSpPr>
         <p:spPr>
           <a:xfrm>
-            <a:off x="5943600" y="4023360"/>
-            <a:ext cx="2011680" cy="960120"/>
+            <a:off x="5943600" y="4069080"/>
+            <a:ext cx="2011680" cy="868680"/>
           </a:xfrm>
           <a:prstGeom prst="diamond">
             <a:avLst/>
@@ -37184,7 +37336,7 @@
         </p:nvSpPr>
         <p:spPr>
           <a:xfrm>
-            <a:off x="5815584" y="3895344"/>
+            <a:off x="5815584" y="3941064"/>
             <a:ext cx="310896" cy="310896"/>
           </a:xfrm>
           <a:prstGeom prst="ellipse">
@@ -37240,8 +37392,8 @@
         </p:nvSpPr>
         <p:spPr>
           <a:xfrm>
-            <a:off x="6035040" y="3429000"/>
-            <a:ext cx="1828800" cy="411480"/>
+            <a:off x="6035040" y="3337560"/>
+            <a:ext cx="1828800" cy="384048"/>
           </a:xfrm>
           <a:prstGeom prst="roundRect">
             <a:avLst>
@@ -37285,7 +37437,7 @@
                   <a:srgbClr val="0B3D7A"/>
                 </a:solidFill>
               </a:rPr>
-              <a:t>no: stop, fix, re-run</a:t>
+              <a:t>stop, fix, re-run</a:t>
             </a:r>
           </a:p>
         </p:txBody>
@@ -39467,7 +39619,7 @@
         <p:spPr>
           <a:xfrm flipH="1">
             <a:off x="18150839" y="3749039"/>
-            <a:ext cx="1" cy="274321"/>
+            <a:ext cx="1" cy="320041"/>
           </a:xfrm>
           <a:prstGeom prst="line">
             <a:avLst/>
@@ -39502,8 +39654,8 @@
         </p:nvCxnSpPr>
         <p:spPr>
           <a:xfrm>
-            <a:off x="18150839" y="4983480"/>
-            <a:ext cx="0" cy="137160"/>
+            <a:off x="18150839" y="4937760"/>
+            <a:ext cx="0" cy="320040"/>
           </a:xfrm>
           <a:prstGeom prst="line">
             <a:avLst/>
@@ -39538,8 +39690,8 @@
         </p:nvSpPr>
         <p:spPr>
           <a:xfrm>
-            <a:off x="18242280" y="4668012"/>
-            <a:ext cx="2926080" cy="365760"/>
+            <a:off x="18214848" y="4960620"/>
+            <a:ext cx="1097280" cy="274320"/>
           </a:xfrm>
           <a:prstGeom prst="rect">
             <a:avLst/>
@@ -39547,7 +39699,7 @@
           <a:noFill/>
         </p:spPr>
         <p:txBody>
-          <a:bodyPr wrap="square" anchor="b" lIns="0" rIns="0" tIns="54864" bIns="54864">
+          <a:bodyPr wrap="square" anchor="ctr" lIns="0" rIns="0" tIns="54864" bIns="54864">
             <a:spAutoFit/>
           </a:bodyPr>
           <a:lstStyle/>
@@ -39604,16 +39756,54 @@
           </a:fontRef>
         </p:style>
       </p:cxnSp>
+      <p:sp>
+        <p:nvSpPr>
+          <p:cNvPr id="93" name="TextBox 92"/>
+          <p:cNvSpPr txBox="1"/>
+          <p:nvPr/>
+        </p:nvSpPr>
+        <p:spPr>
+          <a:xfrm>
+            <a:off x="16322039" y="4192524"/>
+            <a:ext cx="1097280" cy="274320"/>
+          </a:xfrm>
+          <a:prstGeom prst="rect">
+            <a:avLst/>
+          </a:prstGeom>
+          <a:noFill/>
+        </p:spPr>
+        <p:txBody>
+          <a:bodyPr wrap="square" anchor="b" lIns="0" rIns="0" tIns="54864" bIns="54864">
+            <a:spAutoFit/>
+          </a:bodyPr>
+          <a:lstStyle/>
+          <a:p>
+            <a:pPr algn="ctr">
+              <a:spcAft>
+                <a:spcPts val="600"/>
+              </a:spcAft>
+            </a:pPr>
+            <a:r>
+              <a:rPr sz="1100" b="1">
+                <a:solidFill>
+                  <a:srgbClr val="F5EFE9"/>
+                </a:solidFill>
+              </a:rPr>
+              <a:t>yes</a:t>
+            </a:r>
+          </a:p>
+        </p:txBody>
+      </p:sp>
       <p:cxnSp>
         <p:nvCxnSpPr>
-          <p:cNvPr id="93" name="Connector 92"/>
+          <p:cNvPr id="94" name="Connector 93"/>
           <p:cNvCxnSpPr/>
           <p:nvPr/>
         </p:nvCxnSpPr>
         <p:spPr>
           <a:xfrm>
-            <a:off x="15453359" y="4983480"/>
-            <a:ext cx="0" cy="137160"/>
+            <a:off x="15453359" y="4937760"/>
+            <a:ext cx="0" cy="320040"/>
           </a:xfrm>
           <a:prstGeom prst="line">
             <a:avLst/>
@@ -39642,14 +39832,14 @@
       </p:cxnSp>
       <p:sp>
         <p:nvSpPr>
-          <p:cNvPr id="94" name="TextBox 93"/>
+          <p:cNvPr id="95" name="TextBox 94"/>
           <p:cNvSpPr txBox="1"/>
           <p:nvPr/>
         </p:nvSpPr>
         <p:spPr>
           <a:xfrm>
-            <a:off x="15544800" y="4668012"/>
-            <a:ext cx="2926080" cy="365760"/>
+            <a:off x="15517367" y="4960620"/>
+            <a:ext cx="1097280" cy="274320"/>
           </a:xfrm>
           <a:prstGeom prst="rect">
             <a:avLst/>
@@ -39657,7 +39847,7 @@
           <a:noFill/>
         </p:spPr>
         <p:txBody>
-          <a:bodyPr wrap="square" anchor="b" lIns="0" rIns="0" tIns="54864" bIns="54864">
+          <a:bodyPr wrap="square" anchor="ctr" lIns="0" rIns="0" tIns="54864" bIns="54864">
             <a:spAutoFit/>
           </a:bodyPr>
           <a:lstStyle/>
@@ -39680,7 +39870,7 @@
       </p:sp>
       <p:cxnSp>
         <p:nvCxnSpPr>
-          <p:cNvPr id="95" name="Connector 94"/>
+          <p:cNvPr id="96" name="Connector 95"/>
           <p:cNvCxnSpPr/>
           <p:nvPr/>
         </p:nvCxnSpPr>
@@ -39714,9 +39904,47 @@
           </a:fontRef>
         </p:style>
       </p:cxnSp>
+      <p:sp>
+        <p:nvSpPr>
+          <p:cNvPr id="97" name="TextBox 96"/>
+          <p:cNvSpPr txBox="1"/>
+          <p:nvPr/>
+        </p:nvSpPr>
+        <p:spPr>
+          <a:xfrm>
+            <a:off x="13487400" y="4192524"/>
+            <a:ext cx="1097280" cy="274320"/>
+          </a:xfrm>
+          <a:prstGeom prst="rect">
+            <a:avLst/>
+          </a:prstGeom>
+          <a:noFill/>
+        </p:spPr>
+        <p:txBody>
+          <a:bodyPr wrap="square" anchor="b" lIns="0" rIns="0" tIns="54864" bIns="54864">
+            <a:spAutoFit/>
+          </a:bodyPr>
+          <a:lstStyle/>
+          <a:p>
+            <a:pPr algn="ctr">
+              <a:spcAft>
+                <a:spcPts val="600"/>
+              </a:spcAft>
+            </a:pPr>
+            <a:r>
+              <a:rPr sz="1100" b="1">
+                <a:solidFill>
+                  <a:srgbClr val="F5EFE9"/>
+                </a:solidFill>
+              </a:rPr>
+              <a:t>yes</a:t>
+            </a:r>
+          </a:p>
+        </p:txBody>
+      </p:sp>
       <p:cxnSp>
         <p:nvCxnSpPr>
-          <p:cNvPr id="96" name="Connector 95"/>
+          <p:cNvPr id="98" name="Connector 97"/>
           <p:cNvCxnSpPr/>
           <p:nvPr/>
         </p:nvCxnSpPr>
@@ -39752,7 +39980,7 @@
       </p:cxnSp>
       <p:cxnSp>
         <p:nvCxnSpPr>
-          <p:cNvPr id="97" name="Connector 96"/>
+          <p:cNvPr id="99" name="Connector 98"/>
           <p:cNvCxnSpPr/>
           <p:nvPr/>
         </p:nvCxnSpPr>
@@ -39788,14 +40016,14 @@
       </p:cxnSp>
       <p:cxnSp>
         <p:nvCxnSpPr>
-          <p:cNvPr id="98" name="Connector 97"/>
+          <p:cNvPr id="100" name="Connector 99"/>
           <p:cNvCxnSpPr/>
           <p:nvPr/>
         </p:nvCxnSpPr>
         <p:spPr>
           <a:xfrm flipV="1">
-            <a:off x="6949440" y="3840480"/>
-            <a:ext cx="0" cy="182880"/>
+            <a:off x="6949440" y="3721608"/>
+            <a:ext cx="0" cy="347472"/>
           </a:xfrm>
           <a:prstGeom prst="line">
             <a:avLst/>
@@ -39824,14 +40052,14 @@
       </p:cxnSp>
       <p:sp>
         <p:nvSpPr>
-          <p:cNvPr id="99" name="TextBox 98"/>
+          <p:cNvPr id="101" name="TextBox 100"/>
           <p:cNvSpPr txBox="1"/>
           <p:nvPr/>
         </p:nvSpPr>
         <p:spPr>
           <a:xfrm>
-            <a:off x="7040879" y="3547872"/>
-            <a:ext cx="2926080" cy="365760"/>
+            <a:off x="7013448" y="3758183"/>
+            <a:ext cx="1097280" cy="274320"/>
           </a:xfrm>
           <a:prstGeom prst="rect">
             <a:avLst/>
@@ -39839,7 +40067,7 @@
           <a:noFill/>
         </p:spPr>
         <p:txBody>
-          <a:bodyPr wrap="square" anchor="b" lIns="0" rIns="0" tIns="54864" bIns="54864">
+          <a:bodyPr wrap="square" anchor="ctr" lIns="0" rIns="0" tIns="54864" bIns="54864">
             <a:spAutoFit/>
           </a:bodyPr>
           <a:lstStyle/>
@@ -39862,7 +40090,7 @@
       </p:sp>
       <p:cxnSp>
         <p:nvCxnSpPr>
-          <p:cNvPr id="100" name="Connector 99"/>
+          <p:cNvPr id="102" name="Connector 101"/>
           <p:cNvCxnSpPr/>
           <p:nvPr/>
         </p:nvCxnSpPr>
@@ -39896,9 +40124,47 @@
           </a:fontRef>
         </p:style>
       </p:cxnSp>
+      <p:sp>
+        <p:nvSpPr>
+          <p:cNvPr id="103" name="TextBox 102"/>
+          <p:cNvSpPr txBox="1"/>
+          <p:nvPr/>
+        </p:nvSpPr>
+        <p:spPr>
+          <a:xfrm>
+            <a:off x="5189220" y="4192524"/>
+            <a:ext cx="1097280" cy="274320"/>
+          </a:xfrm>
+          <a:prstGeom prst="rect">
+            <a:avLst/>
+          </a:prstGeom>
+          <a:noFill/>
+        </p:spPr>
+        <p:txBody>
+          <a:bodyPr wrap="square" anchor="b" lIns="0" rIns="0" tIns="54864" bIns="54864">
+            <a:spAutoFit/>
+          </a:bodyPr>
+          <a:lstStyle/>
+          <a:p>
+            <a:pPr algn="ctr">
+              <a:spcAft>
+                <a:spcPts val="600"/>
+              </a:spcAft>
+            </a:pPr>
+            <a:r>
+              <a:rPr sz="1100" b="1">
+                <a:solidFill>
+                  <a:srgbClr val="F5EFE9"/>
+                </a:solidFill>
+              </a:rPr>
+              <a:t>yes</a:t>
+            </a:r>
+          </a:p>
+        </p:txBody>
+      </p:sp>
       <p:cxnSp>
         <p:nvCxnSpPr>
-          <p:cNvPr id="101" name="Connector 100"/>
+          <p:cNvPr id="104" name="Connector 103"/>
           <p:cNvCxnSpPr/>
           <p:nvPr/>
         </p:nvCxnSpPr>
@@ -39934,7 +40200,7 @@
       </p:cxnSp>
       <p:cxnSp>
         <p:nvCxnSpPr>
-          <p:cNvPr id="102" name="Connector 101"/>
+          <p:cNvPr id="105" name="Connector 104"/>
           <p:cNvCxnSpPr/>
           <p:nvPr/>
         </p:nvCxnSpPr>
@@ -39969,7 +40235,7 @@
       </p:cxnSp>
       <p:cxnSp>
         <p:nvCxnSpPr>
-          <p:cNvPr id="103" name="Connector 102"/>
+          <p:cNvPr id="106" name="Connector 105"/>
           <p:cNvCxnSpPr/>
           <p:nvPr/>
         </p:nvCxnSpPr>
@@ -40004,7 +40270,7 @@
       </p:cxnSp>
       <p:cxnSp>
         <p:nvCxnSpPr>
-          <p:cNvPr id="104" name="Connector 103"/>
+          <p:cNvPr id="107" name="Connector 106"/>
           <p:cNvCxnSpPr/>
           <p:nvPr/>
         </p:nvCxnSpPr>
@@ -40040,7 +40306,7 @@
       </p:cxnSp>
       <p:sp>
         <p:nvSpPr>
-          <p:cNvPr id="105" name="TextBox 104"/>
+          <p:cNvPr id="108" name="TextBox 107"/>
           <p:cNvSpPr txBox="1"/>
           <p:nvPr/>
         </p:nvSpPr>
@@ -40078,7 +40344,7 @@
       </p:sp>
       <p:cxnSp>
         <p:nvCxnSpPr>
-          <p:cNvPr id="106" name="Connector 105"/>
+          <p:cNvPr id="109" name="Connector 108"/>
           <p:cNvCxnSpPr/>
           <p:nvPr/>
         </p:nvCxnSpPr>
@@ -40114,7 +40380,7 @@
       </p:cxnSp>
       <p:cxnSp>
         <p:nvCxnSpPr>
-          <p:cNvPr id="107" name="Connector 106"/>
+          <p:cNvPr id="110" name="Connector 109"/>
           <p:cNvCxnSpPr/>
           <p:nvPr/>
         </p:nvCxnSpPr>
@@ -40150,7 +40416,7 @@
       </p:cxnSp>
       <p:cxnSp>
         <p:nvCxnSpPr>
-          <p:cNvPr id="108" name="Connector 107"/>
+          <p:cNvPr id="111" name="Connector 110"/>
           <p:cNvCxnSpPr/>
           <p:nvPr/>
         </p:nvCxnSpPr>
@@ -40186,7 +40452,7 @@
       </p:cxnSp>
       <p:cxnSp>
         <p:nvCxnSpPr>
-          <p:cNvPr id="109" name="Connector 108"/>
+          <p:cNvPr id="112" name="Connector 111"/>
           <p:cNvCxnSpPr/>
           <p:nvPr/>
         </p:nvCxnSpPr>
@@ -40222,7 +40488,7 @@
       </p:cxnSp>
       <p:cxnSp>
         <p:nvCxnSpPr>
-          <p:cNvPr id="110" name="Connector 109"/>
+          <p:cNvPr id="113" name="Connector 112"/>
           <p:cNvCxnSpPr/>
           <p:nvPr/>
         </p:nvCxnSpPr>
@@ -40257,7 +40523,7 @@
       </p:cxnSp>
       <p:cxnSp>
         <p:nvCxnSpPr>
-          <p:cNvPr id="111" name="Connector 110"/>
+          <p:cNvPr id="114" name="Connector 113"/>
           <p:cNvCxnSpPr/>
           <p:nvPr/>
         </p:nvCxnSpPr>
@@ -40292,7 +40558,7 @@
       </p:cxnSp>
       <p:cxnSp>
         <p:nvCxnSpPr>
-          <p:cNvPr id="112" name="Connector 111"/>
+          <p:cNvPr id="115" name="Connector 114"/>
           <p:cNvCxnSpPr/>
           <p:nvPr/>
         </p:nvCxnSpPr>
@@ -40328,7 +40594,7 @@
       </p:cxnSp>
       <p:cxnSp>
         <p:nvCxnSpPr>
-          <p:cNvPr id="113" name="Connector 112"/>
+          <p:cNvPr id="116" name="Connector 115"/>
           <p:cNvCxnSpPr/>
           <p:nvPr/>
         </p:nvCxnSpPr>
@@ -40363,7 +40629,7 @@
       </p:cxnSp>
       <p:cxnSp>
         <p:nvCxnSpPr>
-          <p:cNvPr id="114" name="Connector 113"/>
+          <p:cNvPr id="117" name="Connector 116"/>
           <p:cNvCxnSpPr/>
           <p:nvPr/>
         </p:nvCxnSpPr>
@@ -40398,7 +40664,7 @@
       </p:cxnSp>
       <p:cxnSp>
         <p:nvCxnSpPr>
-          <p:cNvPr id="115" name="Connector 114"/>
+          <p:cNvPr id="118" name="Connector 117"/>
           <p:cNvCxnSpPr/>
           <p:nvPr/>
         </p:nvCxnSpPr>
@@ -40434,7 +40700,7 @@
       </p:cxnSp>
       <p:cxnSp>
         <p:nvCxnSpPr>
-          <p:cNvPr id="116" name="Connector 115"/>
+          <p:cNvPr id="119" name="Connector 118"/>
           <p:cNvCxnSpPr/>
           <p:nvPr/>
         </p:nvCxnSpPr>
@@ -40469,7 +40735,7 @@
       </p:cxnSp>
       <p:cxnSp>
         <p:nvCxnSpPr>
-          <p:cNvPr id="117" name="Connector 116"/>
+          <p:cNvPr id="120" name="Connector 119"/>
           <p:cNvCxnSpPr/>
           <p:nvPr/>
         </p:nvCxnSpPr>
@@ -40504,7 +40770,7 @@
       </p:cxnSp>
       <p:cxnSp>
         <p:nvCxnSpPr>
-          <p:cNvPr id="118" name="Connector 117"/>
+          <p:cNvPr id="121" name="Connector 120"/>
           <p:cNvCxnSpPr/>
           <p:nvPr/>
         </p:nvCxnSpPr>
@@ -40540,7 +40806,7 @@
       </p:cxnSp>
       <p:cxnSp>
         <p:nvCxnSpPr>
-          <p:cNvPr id="119" name="Connector 118"/>
+          <p:cNvPr id="122" name="Connector 121"/>
           <p:cNvCxnSpPr/>
           <p:nvPr/>
         </p:nvCxnSpPr>
@@ -40575,7 +40841,7 @@
       </p:cxnSp>
       <p:cxnSp>
         <p:nvCxnSpPr>
-          <p:cNvPr id="120" name="Connector 119"/>
+          <p:cNvPr id="123" name="Connector 122"/>
           <p:cNvCxnSpPr/>
           <p:nvPr/>
         </p:nvCxnSpPr>
@@ -40610,7 +40876,7 @@
       </p:cxnSp>
       <p:cxnSp>
         <p:nvCxnSpPr>
-          <p:cNvPr id="121" name="Connector 120"/>
+          <p:cNvPr id="124" name="Connector 123"/>
           <p:cNvCxnSpPr/>
           <p:nvPr/>
         </p:nvCxnSpPr>
@@ -40646,7 +40912,7 @@
       </p:cxnSp>
       <p:cxnSp>
         <p:nvCxnSpPr>
-          <p:cNvPr id="122" name="Connector 121"/>
+          <p:cNvPr id="125" name="Connector 124"/>
           <p:cNvCxnSpPr/>
           <p:nvPr/>
         </p:nvCxnSpPr>
@@ -40682,7 +40948,7 @@
       </p:cxnSp>
       <p:sp>
         <p:nvSpPr>
-          <p:cNvPr id="123" name="TextBox 122"/>
+          <p:cNvPr id="126" name="TextBox 125"/>
           <p:cNvSpPr txBox="1"/>
           <p:nvPr/>
         </p:nvSpPr>
@@ -40713,7 +40979,7 @@
                   <a:srgbClr val="F5EFE9"/>
                 </a:solidFill>
               </a:rPr>
-              <a:t>Every box in the map is one database object the domains read: seven rolling snapshot tables, the SA aged-balance table with its lookup seed, and eight CMS views. Numbers are the order of one rollout; orange diamonds are gates and a 'no' stops it there. The loop under the second row is the twice-daily rolling refresh (3 months rebuilt, 24 kept; 6 months at CityCorp and Odessa).</a:t>
+              <a:t>Every box in the map is one database object the domains read: seven rolling snapshot tables, the SA aged-balance table with its lookup seed, and eight CMS views. Numbers are the order of one rollout; orange diamonds are gates: yes continues, no stops the rollout there. The loop under the second row is the twice-daily rolling refresh (3 months rebuilt, 24 kept; 6 months at CityCorp and Odessa).</a:t>
             </a:r>
           </a:p>
         </p:txBody>

</xml_diff>

<commit_message>
Text can never leave its box: a shared measured text-fit (Arial, PIL) in both the pptx builder and the draw.io converter, scaling down to 7pt at most and failing the build otherwise; the map columns widened so every table and view name sits at 9pt instead of being shrunk
Co-Authored-By: Claude Fable 5.1 <noreply@anthropic.com>
</commit_message>
<xml_diff>
--- a/jaspersoft/docs/OriginBA_Automated_Deployment.pptx
+++ b/jaspersoft/docs/OriginBA_Automated_Deployment.pptx
@@ -35115,7 +35115,7 @@
         <p:spPr>
           <a:xfrm>
             <a:off x="868680" y="6355080"/>
-            <a:ext cx="2103120" cy="2377440"/>
+            <a:ext cx="2606040" cy="2377440"/>
           </a:xfrm>
           <a:prstGeom prst="roundRect">
             <a:avLst>
@@ -35161,7 +35161,7 @@
         <p:spPr>
           <a:xfrm>
             <a:off x="1033271" y="6400800"/>
-            <a:ext cx="1773936" cy="411480"/>
+            <a:ext cx="2276856" cy="411480"/>
           </a:xfrm>
           <a:prstGeom prst="rect">
             <a:avLst/>
@@ -35198,8 +35198,8 @@
         </p:nvSpPr>
         <p:spPr>
           <a:xfrm>
-            <a:off x="3108960" y="6355080"/>
-            <a:ext cx="2103120" cy="2377440"/>
+            <a:off x="3584448" y="6355080"/>
+            <a:ext cx="2606040" cy="2377440"/>
           </a:xfrm>
           <a:prstGeom prst="roundRect">
             <a:avLst>
@@ -35244,8 +35244,8 @@
         </p:nvSpPr>
         <p:spPr>
           <a:xfrm>
-            <a:off x="3273552" y="6400800"/>
-            <a:ext cx="1773936" cy="411480"/>
+            <a:off x="3749039" y="6400800"/>
+            <a:ext cx="2276856" cy="411480"/>
           </a:xfrm>
           <a:prstGeom prst="rect">
             <a:avLst/>
@@ -35282,8 +35282,8 @@
         </p:nvSpPr>
         <p:spPr>
           <a:xfrm>
-            <a:off x="5349240" y="6355080"/>
-            <a:ext cx="2103120" cy="2377440"/>
+            <a:off x="6300216" y="6355080"/>
+            <a:ext cx="2606040" cy="2377440"/>
           </a:xfrm>
           <a:prstGeom prst="roundRect">
             <a:avLst>
@@ -35328,8 +35328,8 @@
         </p:nvSpPr>
         <p:spPr>
           <a:xfrm>
-            <a:off x="5513831" y="6400800"/>
-            <a:ext cx="1773936" cy="411480"/>
+            <a:off x="6464807" y="6400800"/>
+            <a:ext cx="2276856" cy="411480"/>
           </a:xfrm>
           <a:prstGeom prst="rect">
             <a:avLst/>
@@ -35366,7 +35366,7 @@
         </p:nvSpPr>
         <p:spPr>
           <a:xfrm>
-            <a:off x="7863840" y="6355080"/>
+            <a:off x="9015984" y="6355080"/>
             <a:ext cx="2377440" cy="2377440"/>
           </a:xfrm>
           <a:prstGeom prst="roundRect">
@@ -35412,7 +35412,7 @@
         </p:nvSpPr>
         <p:spPr>
           <a:xfrm>
-            <a:off x="8028431" y="6400800"/>
+            <a:off x="9180576" y="6400800"/>
             <a:ext cx="2048256" cy="411480"/>
           </a:xfrm>
           <a:prstGeom prst="rect">
@@ -35450,8 +35450,8 @@
         </p:nvSpPr>
         <p:spPr>
           <a:xfrm>
-            <a:off x="10515600" y="6355080"/>
-            <a:ext cx="2971800" cy="2377440"/>
+            <a:off x="11503152" y="6355080"/>
+            <a:ext cx="2651760" cy="2377440"/>
           </a:xfrm>
           <a:prstGeom prst="roundRect">
             <a:avLst>
@@ -35496,8 +35496,8 @@
         </p:nvSpPr>
         <p:spPr>
           <a:xfrm>
-            <a:off x="10680192" y="6400800"/>
-            <a:ext cx="2642616" cy="411480"/>
+            <a:off x="11667744" y="6400800"/>
+            <a:ext cx="2322576" cy="411480"/>
           </a:xfrm>
           <a:prstGeom prst="rect">
             <a:avLst/>
@@ -35534,8 +35534,8 @@
         </p:nvSpPr>
         <p:spPr>
           <a:xfrm>
-            <a:off x="13716000" y="6355080"/>
-            <a:ext cx="3063240" cy="2377440"/>
+            <a:off x="14264640" y="6355080"/>
+            <a:ext cx="2697480" cy="2377440"/>
           </a:xfrm>
           <a:prstGeom prst="roundRect">
             <a:avLst>
@@ -35580,8 +35580,8 @@
         </p:nvSpPr>
         <p:spPr>
           <a:xfrm>
-            <a:off x="13880592" y="6400800"/>
-            <a:ext cx="2734056" cy="411480"/>
+            <a:off x="14429232" y="6400800"/>
+            <a:ext cx="2368296" cy="411480"/>
           </a:xfrm>
           <a:prstGeom prst="rect">
             <a:avLst/>
@@ -35618,8 +35618,8 @@
         </p:nvSpPr>
         <p:spPr>
           <a:xfrm>
-            <a:off x="17007840" y="6355080"/>
-            <a:ext cx="2194560" cy="2377440"/>
+            <a:off x="17071848" y="6355080"/>
+            <a:ext cx="2148840" cy="2377440"/>
           </a:xfrm>
           <a:prstGeom prst="roundRect">
             <a:avLst>
@@ -35664,8 +35664,8 @@
         </p:nvSpPr>
         <p:spPr>
           <a:xfrm>
-            <a:off x="17172432" y="6400800"/>
-            <a:ext cx="1865376" cy="411480"/>
+            <a:off x="17236440" y="6400800"/>
+            <a:ext cx="1819656" cy="411480"/>
           </a:xfrm>
           <a:prstGeom prst="rect">
             <a:avLst/>
@@ -37762,7 +37762,7 @@
         <p:spPr>
           <a:xfrm>
             <a:off x="960120" y="6766560"/>
-            <a:ext cx="1920240" cy="777240"/>
+            <a:ext cx="2423160" cy="777240"/>
           </a:xfrm>
           <a:prstGeom prst="roundRect">
             <a:avLst>
@@ -37801,7 +37801,7 @@
               </a:spcAft>
             </a:pPr>
             <a:r>
-              <a:rPr sz="1100" b="1">
+              <a:rPr sz="900" b="1">
                 <a:solidFill>
                   <a:srgbClr val="0B3D7A"/>
                 </a:solidFill>
@@ -37835,7 +37835,7 @@
         <p:spPr>
           <a:xfrm>
             <a:off x="960120" y="7680960"/>
-            <a:ext cx="1920240" cy="777240"/>
+            <a:ext cx="2423160" cy="777240"/>
           </a:xfrm>
           <a:prstGeom prst="roundRect">
             <a:avLst>
@@ -37907,8 +37907,8 @@
         </p:nvSpPr>
         <p:spPr>
           <a:xfrm>
-            <a:off x="3200400" y="6766560"/>
-            <a:ext cx="1920240" cy="777240"/>
+            <a:off x="3675887" y="6766560"/>
+            <a:ext cx="2423160" cy="777240"/>
           </a:xfrm>
           <a:prstGeom prst="roundRect">
             <a:avLst>
@@ -37980,8 +37980,8 @@
         </p:nvSpPr>
         <p:spPr>
           <a:xfrm>
-            <a:off x="3200400" y="7680960"/>
-            <a:ext cx="1920240" cy="777240"/>
+            <a:off x="3675887" y="7680960"/>
+            <a:ext cx="2423160" cy="777240"/>
           </a:xfrm>
           <a:prstGeom prst="roundRect">
             <a:avLst>
@@ -38053,8 +38053,8 @@
         </p:nvSpPr>
         <p:spPr>
           <a:xfrm>
-            <a:off x="5440680" y="6766560"/>
-            <a:ext cx="1920240" cy="566928"/>
+            <a:off x="6391656" y="6766560"/>
+            <a:ext cx="2423160" cy="566928"/>
           </a:xfrm>
           <a:prstGeom prst="roundRect">
             <a:avLst>
@@ -38126,8 +38126,8 @@
         </p:nvSpPr>
         <p:spPr>
           <a:xfrm>
-            <a:off x="5440680" y="7424927"/>
-            <a:ext cx="1920240" cy="566928"/>
+            <a:off x="6391656" y="7424927"/>
+            <a:ext cx="2423160" cy="566928"/>
           </a:xfrm>
           <a:prstGeom prst="roundRect">
             <a:avLst>
@@ -38199,8 +38199,8 @@
         </p:nvSpPr>
         <p:spPr>
           <a:xfrm>
-            <a:off x="5440680" y="8083296"/>
-            <a:ext cx="1920240" cy="566928"/>
+            <a:off x="6391656" y="8083296"/>
+            <a:ext cx="2423160" cy="566928"/>
           </a:xfrm>
           <a:prstGeom prst="roundRect">
             <a:avLst>
@@ -38239,7 +38239,7 @@
               </a:spcAft>
             </a:pPr>
             <a:r>
-              <a:rPr sz="850" b="1">
+              <a:rPr sz="900" b="1">
                 <a:solidFill>
                   <a:srgbClr val="0B3D7A"/>
                 </a:solidFill>
@@ -38273,7 +38273,7 @@
         <p:spPr>
           <a:xfrm>
             <a:off x="868680" y="9006840"/>
-            <a:ext cx="2103120" cy="548640"/>
+            <a:ext cx="2606040" cy="548640"/>
           </a:xfrm>
           <a:prstGeom prst="roundRect">
             <a:avLst>
@@ -38330,8 +38330,8 @@
         </p:nvSpPr>
         <p:spPr>
           <a:xfrm>
-            <a:off x="3108960" y="9006840"/>
-            <a:ext cx="2103120" cy="548640"/>
+            <a:off x="3584448" y="9006840"/>
+            <a:ext cx="2606040" cy="548640"/>
           </a:xfrm>
           <a:prstGeom prst="roundRect">
             <a:avLst>
@@ -38388,8 +38388,8 @@
         </p:nvSpPr>
         <p:spPr>
           <a:xfrm>
-            <a:off x="5349240" y="9006840"/>
-            <a:ext cx="2103120" cy="548640"/>
+            <a:off x="6300216" y="9006840"/>
+            <a:ext cx="2606040" cy="548640"/>
           </a:xfrm>
           <a:prstGeom prst="roundRect">
             <a:avLst>
@@ -38446,7 +38446,7 @@
         </p:nvSpPr>
         <p:spPr>
           <a:xfrm>
-            <a:off x="7955279" y="6766560"/>
+            <a:off x="9107424" y="6766560"/>
             <a:ext cx="2194560" cy="822960"/>
           </a:xfrm>
           <a:prstGeom prst="roundRect">
@@ -38519,7 +38519,7 @@
         </p:nvSpPr>
         <p:spPr>
           <a:xfrm>
-            <a:off x="7955279" y="7726679"/>
+            <a:off x="9107424" y="7726679"/>
             <a:ext cx="2194560" cy="640080"/>
           </a:xfrm>
           <a:prstGeom prst="roundRect">
@@ -38592,7 +38592,7 @@
         </p:nvSpPr>
         <p:spPr>
           <a:xfrm>
-            <a:off x="7863840" y="9006840"/>
+            <a:off x="9015984" y="9006840"/>
             <a:ext cx="2377440" cy="548640"/>
           </a:xfrm>
           <a:prstGeom prst="roundRect">
@@ -38650,8 +38650,8 @@
         </p:nvSpPr>
         <p:spPr>
           <a:xfrm>
-            <a:off x="10607040" y="6766560"/>
-            <a:ext cx="2788920" cy="457200"/>
+            <a:off x="11594592" y="6766560"/>
+            <a:ext cx="2468880" cy="457200"/>
           </a:xfrm>
           <a:prstGeom prst="roundRect">
             <a:avLst>
@@ -38708,8 +38708,8 @@
         </p:nvSpPr>
         <p:spPr>
           <a:xfrm>
-            <a:off x="10607040" y="7315200"/>
-            <a:ext cx="2788920" cy="457200"/>
+            <a:off x="11594592" y="7315200"/>
+            <a:ext cx="2468880" cy="457200"/>
           </a:xfrm>
           <a:prstGeom prst="roundRect">
             <a:avLst>
@@ -38766,8 +38766,8 @@
         </p:nvSpPr>
         <p:spPr>
           <a:xfrm>
-            <a:off x="10607040" y="7863840"/>
-            <a:ext cx="2788920" cy="457200"/>
+            <a:off x="11594592" y="7863840"/>
+            <a:ext cx="2468880" cy="457200"/>
           </a:xfrm>
           <a:prstGeom prst="roundRect">
             <a:avLst>
@@ -38824,8 +38824,8 @@
         </p:nvSpPr>
         <p:spPr>
           <a:xfrm>
-            <a:off x="10515600" y="9006840"/>
-            <a:ext cx="1417320" cy="548640"/>
+            <a:off x="11503152" y="9006840"/>
+            <a:ext cx="1280160" cy="548640"/>
           </a:xfrm>
           <a:prstGeom prst="roundRect">
             <a:avLst>
@@ -38882,8 +38882,8 @@
         </p:nvSpPr>
         <p:spPr>
           <a:xfrm>
-            <a:off x="12070080" y="9006840"/>
-            <a:ext cx="1417320" cy="548640"/>
+            <a:off x="12874752" y="9006840"/>
+            <a:ext cx="1280160" cy="548640"/>
           </a:xfrm>
           <a:prstGeom prst="roundRect">
             <a:avLst>
@@ -38940,8 +38940,8 @@
         </p:nvSpPr>
         <p:spPr>
           <a:xfrm>
-            <a:off x="13807440" y="6766560"/>
-            <a:ext cx="2880360" cy="457200"/>
+            <a:off x="14356080" y="6766560"/>
+            <a:ext cx="2514600" cy="457200"/>
           </a:xfrm>
           <a:prstGeom prst="roundRect">
             <a:avLst>
@@ -38998,8 +38998,8 @@
         </p:nvSpPr>
         <p:spPr>
           <a:xfrm>
-            <a:off x="13807440" y="7315200"/>
-            <a:ext cx="2880360" cy="457200"/>
+            <a:off x="14356080" y="7315200"/>
+            <a:ext cx="2514600" cy="457200"/>
           </a:xfrm>
           <a:prstGeom prst="roundRect">
             <a:avLst>
@@ -39056,8 +39056,8 @@
         </p:nvSpPr>
         <p:spPr>
           <a:xfrm>
-            <a:off x="13807440" y="7863840"/>
-            <a:ext cx="2880360" cy="457200"/>
+            <a:off x="14356080" y="7863840"/>
+            <a:ext cx="2514600" cy="457200"/>
           </a:xfrm>
           <a:prstGeom prst="roundRect">
             <a:avLst>
@@ -39114,8 +39114,8 @@
         </p:nvSpPr>
         <p:spPr>
           <a:xfrm>
-            <a:off x="13716000" y="9006840"/>
-            <a:ext cx="1463040" cy="548640"/>
+            <a:off x="14264640" y="9006840"/>
+            <a:ext cx="1298448" cy="548640"/>
           </a:xfrm>
           <a:prstGeom prst="roundRect">
             <a:avLst>
@@ -39172,8 +39172,8 @@
         </p:nvSpPr>
         <p:spPr>
           <a:xfrm>
-            <a:off x="15316200" y="9006840"/>
-            <a:ext cx="1463040" cy="548640"/>
+            <a:off x="15663672" y="9006840"/>
+            <a:ext cx="1298448" cy="548640"/>
           </a:xfrm>
           <a:prstGeom prst="roundRect">
             <a:avLst>
@@ -39230,8 +39230,8 @@
         </p:nvSpPr>
         <p:spPr>
           <a:xfrm>
-            <a:off x="17099280" y="6766560"/>
-            <a:ext cx="2011680" cy="457200"/>
+            <a:off x="17163288" y="6766560"/>
+            <a:ext cx="1965960" cy="457200"/>
           </a:xfrm>
           <a:prstGeom prst="roundRect">
             <a:avLst>
@@ -39288,8 +39288,8 @@
         </p:nvSpPr>
         <p:spPr>
           <a:xfrm>
-            <a:off x="17099280" y="7315200"/>
-            <a:ext cx="2011680" cy="457200"/>
+            <a:off x="17163288" y="7315200"/>
+            <a:ext cx="1965960" cy="457200"/>
           </a:xfrm>
           <a:prstGeom prst="roundRect">
             <a:avLst>
@@ -39346,8 +39346,8 @@
         </p:nvSpPr>
         <p:spPr>
           <a:xfrm>
-            <a:off x="17007840" y="9006840"/>
-            <a:ext cx="2194560" cy="548640"/>
+            <a:off x="17071848" y="9006840"/>
+            <a:ext cx="2148840" cy="548640"/>
           </a:xfrm>
           <a:prstGeom prst="roundRect">
             <a:avLst>
@@ -40350,7 +40350,7 @@
         </p:nvCxnSpPr>
         <p:spPr>
           <a:xfrm>
-            <a:off x="1920239" y="8732520"/>
+            <a:off x="2171700" y="8732520"/>
             <a:ext cx="0" cy="274320"/>
           </a:xfrm>
           <a:prstGeom prst="line">
@@ -40386,7 +40386,7 @@
         </p:nvCxnSpPr>
         <p:spPr>
           <a:xfrm>
-            <a:off x="4160520" y="8732520"/>
+            <a:off x="4887468" y="8732520"/>
             <a:ext cx="0" cy="274320"/>
           </a:xfrm>
           <a:prstGeom prst="line">
@@ -40422,7 +40422,7 @@
         </p:nvCxnSpPr>
         <p:spPr>
           <a:xfrm>
-            <a:off x="6400800" y="8732520"/>
+            <a:off x="7603236" y="8732520"/>
             <a:ext cx="0" cy="274320"/>
           </a:xfrm>
           <a:prstGeom prst="line">
@@ -40458,7 +40458,7 @@
         </p:nvCxnSpPr>
         <p:spPr>
           <a:xfrm>
-            <a:off x="9052560" y="8732520"/>
+            <a:off x="10204704" y="8732520"/>
             <a:ext cx="0" cy="274320"/>
           </a:xfrm>
           <a:prstGeom prst="line">
@@ -40494,7 +40494,7 @@
         </p:nvCxnSpPr>
         <p:spPr>
           <a:xfrm>
-            <a:off x="12001500" y="8732520"/>
+            <a:off x="12829032" y="8732520"/>
             <a:ext cx="0" cy="137160"/>
           </a:xfrm>
           <a:prstGeom prst="line">
@@ -40529,8 +40529,8 @@
         </p:nvCxnSpPr>
         <p:spPr>
           <a:xfrm flipH="1">
-            <a:off x="11219688" y="8869680"/>
-            <a:ext cx="781812" cy="0"/>
+            <a:off x="12143232" y="8869680"/>
+            <a:ext cx="685800" cy="0"/>
           </a:xfrm>
           <a:prstGeom prst="line">
             <a:avLst/>
@@ -40564,8 +40564,8 @@
         </p:nvCxnSpPr>
         <p:spPr>
           <a:xfrm>
-            <a:off x="11219688" y="8869680"/>
-            <a:ext cx="4572" cy="137160"/>
+            <a:off x="12143232" y="8869680"/>
+            <a:ext cx="0" cy="137160"/>
           </a:xfrm>
           <a:prstGeom prst="line">
             <a:avLst/>
@@ -40600,7 +40600,7 @@
         </p:nvCxnSpPr>
         <p:spPr>
           <a:xfrm>
-            <a:off x="12001500" y="8732520"/>
+            <a:off x="12829032" y="8732520"/>
             <a:ext cx="0" cy="137160"/>
           </a:xfrm>
           <a:prstGeom prst="line">
@@ -40635,8 +40635,8 @@
         </p:nvCxnSpPr>
         <p:spPr>
           <a:xfrm>
-            <a:off x="12001500" y="8869680"/>
-            <a:ext cx="772668" cy="0"/>
+            <a:off x="12829032" y="8869680"/>
+            <a:ext cx="685800" cy="0"/>
           </a:xfrm>
           <a:prstGeom prst="line">
             <a:avLst/>
@@ -40670,8 +40670,8 @@
         </p:nvCxnSpPr>
         <p:spPr>
           <a:xfrm>
-            <a:off x="12774168" y="8869680"/>
-            <a:ext cx="4572" cy="137160"/>
+            <a:off x="13514832" y="8869680"/>
+            <a:ext cx="0" cy="137160"/>
           </a:xfrm>
           <a:prstGeom prst="line">
             <a:avLst/>
@@ -40706,7 +40706,7 @@
         </p:nvCxnSpPr>
         <p:spPr>
           <a:xfrm>
-            <a:off x="15247620" y="8732520"/>
+            <a:off x="15613380" y="8732520"/>
             <a:ext cx="0" cy="137160"/>
           </a:xfrm>
           <a:prstGeom prst="line">
@@ -40741,8 +40741,8 @@
         </p:nvCxnSpPr>
         <p:spPr>
           <a:xfrm flipH="1">
-            <a:off x="14447520" y="8869680"/>
-            <a:ext cx="800100" cy="0"/>
+            <a:off x="14913863" y="8869680"/>
+            <a:ext cx="699517" cy="0"/>
           </a:xfrm>
           <a:prstGeom prst="line">
             <a:avLst/>
@@ -40776,7 +40776,7 @@
         </p:nvCxnSpPr>
         <p:spPr>
           <a:xfrm>
-            <a:off x="14447520" y="8869680"/>
+            <a:off x="14913863" y="8869680"/>
             <a:ext cx="0" cy="137160"/>
           </a:xfrm>
           <a:prstGeom prst="line">
@@ -40812,7 +40812,7 @@
         </p:nvCxnSpPr>
         <p:spPr>
           <a:xfrm>
-            <a:off x="15247620" y="8732520"/>
+            <a:off x="15613380" y="8732520"/>
             <a:ext cx="0" cy="137160"/>
           </a:xfrm>
           <a:prstGeom prst="line">
@@ -40847,8 +40847,8 @@
         </p:nvCxnSpPr>
         <p:spPr>
           <a:xfrm>
-            <a:off x="15247620" y="8869680"/>
-            <a:ext cx="800100" cy="0"/>
+            <a:off x="15613380" y="8869680"/>
+            <a:ext cx="699516" cy="0"/>
           </a:xfrm>
           <a:prstGeom prst="line">
             <a:avLst/>
@@ -40882,7 +40882,7 @@
         </p:nvCxnSpPr>
         <p:spPr>
           <a:xfrm>
-            <a:off x="16047720" y="8869680"/>
+            <a:off x="16312896" y="8869680"/>
             <a:ext cx="0" cy="137160"/>
           </a:xfrm>
           <a:prstGeom prst="line">
@@ -40918,7 +40918,7 @@
         </p:nvCxnSpPr>
         <p:spPr>
           <a:xfrm>
-            <a:off x="18105120" y="8732520"/>
+            <a:off x="18146268" y="8732520"/>
             <a:ext cx="0" cy="274320"/>
           </a:xfrm>
           <a:prstGeom prst="line">

</xml_diff>

<commit_message>
Page colour: the app's brand navy (#16283C) instead of its near-black background, at Chase's review (too dark)
Co-Authored-By: Claude Opus 5.5 <noreply@anthropic.com>
</commit_message>
<xml_diff>
--- a/jaspersoft/docs/OriginBA_Automated_Deployment.pptx
+++ b/jaspersoft/docs/OriginBA_Automated_Deployment.pptx
@@ -7737,7 +7737,7 @@
             <a:avLst/>
           </a:prstGeom>
           <a:solidFill>
-            <a:srgbClr val="0B1723"/>
+            <a:srgbClr val="16283C"/>
           </a:solidFill>
           <a:ln>
             <a:noFill/>
@@ -7863,7 +7863,7 @@
             <a:avLst/>
           </a:prstGeom>
           <a:solidFill>
-            <a:srgbClr val="0B1723"/>
+            <a:srgbClr val="16283C"/>
           </a:solidFill>
           <a:ln>
             <a:noFill/>
@@ -8723,7 +8723,7 @@
             <a:avLst/>
           </a:prstGeom>
           <a:solidFill>
-            <a:srgbClr val="0B1723"/>
+            <a:srgbClr val="16283C"/>
           </a:solidFill>
           <a:ln>
             <a:noFill/>
@@ -9583,7 +9583,7 @@
             <a:avLst/>
           </a:prstGeom>
           <a:solidFill>
-            <a:srgbClr val="0B1723"/>
+            <a:srgbClr val="16283C"/>
           </a:solidFill>
           <a:ln>
             <a:noFill/>
@@ -10980,7 +10980,7 @@
             <a:avLst/>
           </a:prstGeom>
           <a:solidFill>
-            <a:srgbClr val="0B1723"/>
+            <a:srgbClr val="16283C"/>
           </a:solidFill>
           <a:ln>
             <a:noFill/>
@@ -12658,7 +12658,7 @@
             <a:avLst/>
           </a:prstGeom>
           <a:solidFill>
-            <a:srgbClr val="0B1723"/>
+            <a:srgbClr val="16283C"/>
           </a:solidFill>
           <a:ln>
             <a:noFill/>
@@ -13577,7 +13577,7 @@
             <a:avLst/>
           </a:prstGeom>
           <a:solidFill>
-            <a:srgbClr val="0B1723"/>
+            <a:srgbClr val="16283C"/>
           </a:solidFill>
           <a:ln>
             <a:noFill/>
@@ -18919,7 +18919,7 @@
             <a:avLst/>
           </a:prstGeom>
           <a:solidFill>
-            <a:srgbClr val="0B1723"/>
+            <a:srgbClr val="16283C"/>
           </a:solidFill>
           <a:ln>
             <a:noFill/>
@@ -20316,7 +20316,7 @@
             <a:avLst/>
           </a:prstGeom>
           <a:solidFill>
-            <a:srgbClr val="0B1723"/>
+            <a:srgbClr val="16283C"/>
           </a:solidFill>
           <a:ln>
             <a:noFill/>
@@ -20911,7 +20911,7 @@
             <a:avLst/>
           </a:prstGeom>
           <a:solidFill>
-            <a:srgbClr val="0B1723"/>
+            <a:srgbClr val="16283C"/>
           </a:solidFill>
           <a:ln>
             <a:noFill/>
@@ -21876,7 +21876,7 @@
             <a:avLst/>
           </a:prstGeom>
           <a:solidFill>
-            <a:srgbClr val="0B1723"/>
+            <a:srgbClr val="16283C"/>
           </a:solidFill>
           <a:ln>
             <a:noFill/>
@@ -23299,7 +23299,7 @@
             <a:avLst/>
           </a:prstGeom>
           <a:solidFill>
-            <a:srgbClr val="0B1723"/>
+            <a:srgbClr val="16283C"/>
           </a:solidFill>
           <a:ln>
             <a:noFill/>
@@ -24695,7 +24695,7 @@
             <a:avLst/>
           </a:prstGeom>
           <a:solidFill>
-            <a:srgbClr val="0B1723"/>
+            <a:srgbClr val="16283C"/>
           </a:solidFill>
           <a:ln>
             <a:noFill/>
@@ -25202,7 +25202,7 @@
             <a:avLst/>
           </a:prstGeom>
           <a:solidFill>
-            <a:srgbClr val="0B1723"/>
+            <a:srgbClr val="16283C"/>
           </a:solidFill>
           <a:ln>
             <a:noFill/>
@@ -25911,7 +25911,7 @@
             <a:avLst/>
           </a:prstGeom>
           <a:solidFill>
-            <a:srgbClr val="0B1723"/>
+            <a:srgbClr val="16283C"/>
           </a:solidFill>
           <a:ln>
             <a:noFill/>
@@ -26851,7 +26851,7 @@
             <a:avLst/>
           </a:prstGeom>
           <a:solidFill>
-            <a:srgbClr val="0B1723"/>
+            <a:srgbClr val="16283C"/>
           </a:solidFill>
           <a:ln>
             <a:noFill/>
@@ -27805,7 +27805,7 @@
             <a:avLst/>
           </a:prstGeom>
           <a:solidFill>
-            <a:srgbClr val="0B1723"/>
+            <a:srgbClr val="16283C"/>
           </a:solidFill>
           <a:ln>
             <a:noFill/>
@@ -28310,7 +28310,7 @@
             <a:avLst/>
           </a:prstGeom>
           <a:solidFill>
-            <a:srgbClr val="0B1723"/>
+            <a:srgbClr val="16283C"/>
           </a:solidFill>
           <a:ln>
             <a:noFill/>
@@ -29801,7 +29801,7 @@
             <a:avLst/>
           </a:prstGeom>
           <a:solidFill>
-            <a:srgbClr val="0B1723"/>
+            <a:srgbClr val="16283C"/>
           </a:solidFill>
           <a:ln>
             <a:noFill/>
@@ -31234,7 +31234,7 @@
             <a:avLst/>
           </a:prstGeom>
           <a:solidFill>
-            <a:srgbClr val="0B1723"/>
+            <a:srgbClr val="16283C"/>
           </a:solidFill>
           <a:ln>
             <a:noFill/>
@@ -32341,7 +32341,7 @@
             <a:avLst/>
           </a:prstGeom>
           <a:solidFill>
-            <a:srgbClr val="0B1723"/>
+            <a:srgbClr val="16283C"/>
           </a:solidFill>
           <a:ln>
             <a:noFill/>
@@ -33640,7 +33640,7 @@
             <a:avLst/>
           </a:prstGeom>
           <a:solidFill>
-            <a:srgbClr val="0B1723"/>
+            <a:srgbClr val="16283C"/>
           </a:solidFill>
           <a:ln>
             <a:noFill/>
@@ -35189,7 +35189,7 @@
             <a:avLst/>
           </a:prstGeom>
           <a:solidFill>
-            <a:srgbClr val="0B1723"/>
+            <a:srgbClr val="16283C"/>
           </a:solidFill>
           <a:ln>
             <a:noFill/>
@@ -35784,7 +35784,7 @@
             <a:avLst/>
           </a:prstGeom>
           <a:solidFill>
-            <a:srgbClr val="0B1723"/>
+            <a:srgbClr val="16283C"/>
           </a:solidFill>
           <a:ln>
             <a:noFill/>

</xml_diff>